<commit_message>
Add pptx-format-qa skill + fix policy brief slides
New skill: pptx-format-qa
- SKILL.md: description, GOAP presentation style reference
- format_pptx.py: reusable script checking font sizes, table density,
  font consistency, and GOAP color application in PowerPoint files

Fixes applied to policy-brief-slides.pptx (236 issues, 230 fixes):
- All body text increased from 14pt to 18pt (readable from back of room)
- All table text increased from 10-11pt to 14pt
- Subtitle text increased from 18pt to target sizes
- All fonts normalized to Arial
- Table header rows styled with GOAP green background + white text

Usage:
  python format_pptx.py presentation.pptx
  python format_pptx.py folder/ --recursive
  python format_pptx.py file.pptx --check-only

Co-Authored-By: Claude Opus 4.6 (1M context) <noreply@anthropic.com>
</commit_message>
<xml_diff>
--- a/s-s-event-bogor/sessions/day-3/policy-brief-clinic/policy-brief-slides.pptx
+++ b/s-s-event-bogor/sessions/day-3/policy-brief-clinic/policy-brief-slides.pptx
@@ -38913,7 +38913,7 @@
                 <a:solidFill>
                   <a:srgbClr val="0A5455"/>
                 </a:solidFill>
-                <a:latin typeface="Inter"/>
+                <a:latin typeface="Arial"/>
               </a:rPr>
               <a:t>From Ocean Accounts to Policy Action: Crafting a Policy Brief</a:t>
             </a:r>
@@ -38936,22 +38936,22 @@
           <a:lstStyle/>
           <a:p>
             <a:r>
-              <a:rPr sz="1800">
+              <a:rPr sz="3600">
                 <a:solidFill>
                   <a:srgbClr val="30302F"/>
                 </a:solidFill>
-                <a:latin typeface="Inter"/>
+                <a:latin typeface="Arial"/>
               </a:rPr>
               <a:t>Ocean Accounting Clinic Pt.2</a:t>
             </a:r>
           </a:p>
           <a:p>
             <a:r>
-              <a:rPr sz="1800">
+              <a:rPr sz="3600">
                 <a:solidFill>
                   <a:srgbClr val="30302F"/>
                 </a:solidFill>
-                <a:latin typeface="Inter"/>
+                <a:latin typeface="Arial"/>
               </a:rPr>
               <a:t>Day 3 -- 1 April 2026</a:t>
             </a:r>
@@ -39072,7 +39072,7 @@
                 <a:solidFill>
                   <a:srgbClr val="FFFFFF"/>
                 </a:solidFill>
-                <a:latin typeface="Inter"/>
+                <a:latin typeface="Arial"/>
               </a:rPr>
               <a:t>Slide 9: Anatomy of a GOAP policy brief</a:t>
             </a:r>
@@ -39103,11 +39103,11 @@
           <a:p>
             <a:pPr algn="l"/>
             <a:r>
-              <a:rPr sz="1400" b="0">
+              <a:rPr sz="1800" b="0">
                 <a:solidFill>
                   <a:srgbClr val="30302F"/>
                 </a:solidFill>
-                <a:latin typeface="Inter"/>
+                <a:latin typeface="Arial"/>
               </a:rPr>
               <a:t>The existing GOAP policy briefs follow a consistent structure. Here is what each section does:</a:t>
             </a:r>
@@ -39119,11 +39119,11 @@
               </a:spcBef>
             </a:pPr>
             <a:r>
-              <a:rPr sz="1400" b="0">
+              <a:rPr sz="1800" b="0">
                 <a:solidFill>
                   <a:srgbClr val="30302F"/>
                 </a:solidFill>
-                <a:latin typeface="Inter"/>
+                <a:latin typeface="Arial"/>
               </a:rPr>
               <a:t>Tips for each section:</a:t>
             </a:r>
@@ -39135,11 +39135,11 @@
               </a:spcBef>
             </a:pPr>
             <a:r>
-              <a:rPr sz="1400" b="0">
+              <a:rPr sz="1800" b="0">
                 <a:solidFill>
                   <a:srgbClr val="30302F"/>
                 </a:solidFill>
-                <a:latin typeface="Inter"/>
+                <a:latin typeface="Arial"/>
               </a:rPr>
               <a:t>  Title: Can your reader tell the country and topic from the title alone? "Ocean Accounts for Fiji's Coastal Resilience" works. "Policy Brief" alone does not.</a:t>
             </a:r>
@@ -39151,11 +39151,11 @@
               </a:spcBef>
             </a:pPr>
             <a:r>
-              <a:rPr sz="1400" b="0">
+              <a:rPr sz="1800" b="0">
                 <a:solidFill>
                   <a:srgbClr val="30302F"/>
                 </a:solidFill>
-                <a:latin typeface="Inter"/>
+                <a:latin typeface="Arial"/>
               </a:rPr>
               <a:t>  Key messages: Write these last, after you know what the brief says. Each bullet should stand on its own.</a:t>
             </a:r>
@@ -39167,11 +39167,11 @@
               </a:spcBef>
             </a:pPr>
             <a:r>
-              <a:rPr sz="1400" b="0">
+              <a:rPr sz="1800" b="0">
                 <a:solidFill>
                   <a:srgbClr val="30302F"/>
                 </a:solidFill>
-                <a:latin typeface="Inter"/>
+                <a:latin typeface="Arial"/>
               </a:rPr>
               <a:t>  Context: Lead with the reader's world, not yours. Start with their policy challenge, not your methodology.</a:t>
             </a:r>
@@ -39183,11 +39183,11 @@
               </a:spcBef>
             </a:pPr>
             <a:r>
-              <a:rPr sz="1400" b="0">
+              <a:rPr sz="1800" b="0">
                 <a:solidFill>
                   <a:srgbClr val="30302F"/>
                 </a:solidFill>
-                <a:latin typeface="Inter"/>
+                <a:latin typeface="Arial"/>
               </a:rPr>
               <a:t>  Recommendations: Be specific. "Integrate extent account data into the next NBSAP revision" is actionable. "More research is needed" is not.</a:t>
             </a:r>
@@ -39224,11 +39224,11 @@
                     <a:lstStyle/>
                     <a:p>
                       <a:r>
-                        <a:rPr sz="1100" b="1">
+                        <a:rPr sz="1400" b="1">
                           <a:solidFill>
                             <a:srgbClr val="FFFFFF"/>
                           </a:solidFill>
-                          <a:latin typeface="Inter"/>
+                          <a:latin typeface="Arial"/>
                         </a:rPr>
                         <a:t>Section</a:t>
                       </a:r>
@@ -39246,11 +39246,11 @@
                     <a:lstStyle/>
                     <a:p>
                       <a:r>
-                        <a:rPr sz="1100" b="1">
+                        <a:rPr sz="1400" b="1">
                           <a:solidFill>
                             <a:srgbClr val="FFFFFF"/>
                           </a:solidFill>
-                          <a:latin typeface="Inter"/>
+                          <a:latin typeface="Arial"/>
                         </a:rPr>
                         <a:t>Purpose</a:t>
                       </a:r>
@@ -39268,11 +39268,11 @@
                     <a:lstStyle/>
                     <a:p>
                       <a:r>
-                        <a:rPr sz="1100" b="1">
+                        <a:rPr sz="1400" b="1">
                           <a:solidFill>
                             <a:srgbClr val="FFFFFF"/>
                           </a:solidFill>
-                          <a:latin typeface="Inter"/>
+                          <a:latin typeface="Arial"/>
                         </a:rPr>
                         <a:t>Length</a:t>
                       </a:r>
@@ -39292,11 +39292,11 @@
                     <a:lstStyle/>
                     <a:p>
                       <a:r>
-                        <a:rPr sz="1000">
+                        <a:rPr sz="1400">
                           <a:solidFill>
                             <a:srgbClr val="30302F"/>
                           </a:solidFill>
-                          <a:latin typeface="Inter"/>
+                          <a:latin typeface="Arial"/>
                         </a:rPr>
                         <a:t>Title</a:t>
                       </a:r>
@@ -39310,11 +39310,11 @@
                     <a:lstStyle/>
                     <a:p>
                       <a:r>
-                        <a:rPr sz="1000">
+                        <a:rPr sz="1400">
                           <a:solidFill>
                             <a:srgbClr val="30302F"/>
                           </a:solidFill>
-                          <a:latin typeface="Inter"/>
+                          <a:latin typeface="Arial"/>
                         </a:rPr>
                         <a:t>Action-oriented, names the topic and the connection to ocean accounts</a:t>
                       </a:r>
@@ -39328,11 +39328,11 @@
                     <a:lstStyle/>
                     <a:p>
                       <a:r>
-                        <a:rPr sz="1000">
+                        <a:rPr sz="1400">
                           <a:solidFill>
                             <a:srgbClr val="30302F"/>
                           </a:solidFill>
-                          <a:latin typeface="Inter"/>
+                          <a:latin typeface="Arial"/>
                         </a:rPr>
                         <a:t>1 sentence</a:t>
                       </a:r>
@@ -39348,11 +39348,11 @@
                     <a:lstStyle/>
                     <a:p>
                       <a:r>
-                        <a:rPr sz="1000">
+                        <a:rPr sz="1400">
                           <a:solidFill>
                             <a:srgbClr val="30302F"/>
                           </a:solidFill>
-                          <a:latin typeface="Inter"/>
+                          <a:latin typeface="Arial"/>
                         </a:rPr>
                         <a:t>Key messages</a:t>
                       </a:r>
@@ -39366,11 +39366,11 @@
                     <a:lstStyle/>
                     <a:p>
                       <a:r>
-                        <a:rPr sz="1000">
+                        <a:rPr sz="1400">
                           <a:solidFill>
                             <a:srgbClr val="30302F"/>
                           </a:solidFill>
-                          <a:latin typeface="Inter"/>
+                          <a:latin typeface="Arial"/>
                         </a:rPr>
                         <a:t>4 to 6 bullet points a busy reader can scan in 30 seconds</a:t>
                       </a:r>
@@ -39384,11 +39384,11 @@
                     <a:lstStyle/>
                     <a:p>
                       <a:r>
-                        <a:rPr sz="1000">
+                        <a:rPr sz="1400">
                           <a:solidFill>
                             <a:srgbClr val="30302F"/>
                           </a:solidFill>
-                          <a:latin typeface="Inter"/>
+                          <a:latin typeface="Arial"/>
                         </a:rPr>
                         <a:t>Half page</a:t>
                       </a:r>
@@ -39404,11 +39404,11 @@
                     <a:lstStyle/>
                     <a:p>
                       <a:r>
-                        <a:rPr sz="1000">
+                        <a:rPr sz="1400">
                           <a:solidFill>
                             <a:srgbClr val="30302F"/>
                           </a:solidFill>
-                          <a:latin typeface="Inter"/>
+                          <a:latin typeface="Arial"/>
                         </a:rPr>
                         <a:t>Context / Introduction</a:t>
                       </a:r>
@@ -39422,11 +39422,11 @@
                     <a:lstStyle/>
                     <a:p>
                       <a:r>
-                        <a:rPr sz="1000">
+                        <a:rPr sz="1400">
                           <a:solidFill>
                             <a:srgbClr val="30302F"/>
                           </a:solidFill>
-                          <a:latin typeface="Inter"/>
+                          <a:latin typeface="Arial"/>
                         </a:rPr>
                         <a:t>Why this topic matters, framed for the target audience</a:t>
                       </a:r>
@@ -39440,11 +39440,11 @@
                     <a:lstStyle/>
                     <a:p>
                       <a:r>
-                        <a:rPr sz="1000">
+                        <a:rPr sz="1400">
                           <a:solidFill>
                             <a:srgbClr val="30302F"/>
                           </a:solidFill>
-                          <a:latin typeface="Inter"/>
+                          <a:latin typeface="Arial"/>
                         </a:rPr>
                         <a:t>1 to 2 paragraphs</a:t>
                       </a:r>
@@ -39460,11 +39460,11 @@
                     <a:lstStyle/>
                     <a:p>
                       <a:r>
-                        <a:rPr sz="1000">
+                        <a:rPr sz="1400">
                           <a:solidFill>
                             <a:srgbClr val="30302F"/>
                           </a:solidFill>
-                          <a:latin typeface="Inter"/>
+                          <a:latin typeface="Arial"/>
                         </a:rPr>
                         <a:t>Ocean accounts contribution</a:t>
                       </a:r>
@@ -39478,11 +39478,11 @@
                     <a:lstStyle/>
                     <a:p>
                       <a:r>
-                        <a:rPr sz="1000">
+                        <a:rPr sz="1400">
                           <a:solidFill>
                             <a:srgbClr val="30302F"/>
                           </a:solidFill>
-                          <a:latin typeface="Inter"/>
+                          <a:latin typeface="Arial"/>
                         </a:rPr>
                         <a:t>How ocean accounts address the problem -- the "so what"</a:t>
                       </a:r>
@@ -39496,11 +39496,11 @@
                     <a:lstStyle/>
                     <a:p>
                       <a:r>
-                        <a:rPr sz="1000">
+                        <a:rPr sz="1400">
                           <a:solidFill>
                             <a:srgbClr val="30302F"/>
                           </a:solidFill>
-                          <a:latin typeface="Inter"/>
+                          <a:latin typeface="Arial"/>
                         </a:rPr>
                         <a:t>1 to 2 pages</a:t>
                       </a:r>
@@ -39516,11 +39516,11 @@
                     <a:lstStyle/>
                     <a:p>
                       <a:r>
-                        <a:rPr sz="1000">
+                        <a:rPr sz="1400">
                           <a:solidFill>
                             <a:srgbClr val="30302F"/>
                           </a:solidFill>
-                          <a:latin typeface="Inter"/>
+                          <a:latin typeface="Arial"/>
                         </a:rPr>
                         <a:t>Policy questions or recommendations</a:t>
                       </a:r>
@@ -39534,11 +39534,11 @@
                     <a:lstStyle/>
                     <a:p>
                       <a:r>
-                        <a:rPr sz="1000">
+                        <a:rPr sz="1400">
                           <a:solidFill>
                             <a:srgbClr val="30302F"/>
                           </a:solidFill>
-                          <a:latin typeface="Inter"/>
+                          <a:latin typeface="Arial"/>
                         </a:rPr>
                         <a:t>Specific, actionable steps the reader can take</a:t>
                       </a:r>
@@ -39552,11 +39552,11 @@
                     <a:lstStyle/>
                     <a:p>
                       <a:r>
-                        <a:rPr sz="1000">
+                        <a:rPr sz="1400">
                           <a:solidFill>
                             <a:srgbClr val="30302F"/>
                           </a:solidFill>
-                          <a:latin typeface="Inter"/>
+                          <a:latin typeface="Arial"/>
                         </a:rPr>
                         <a:t>3 to 5 items</a:t>
                       </a:r>
@@ -39572,11 +39572,11 @@
                     <a:lstStyle/>
                     <a:p>
                       <a:r>
-                        <a:rPr sz="1000">
+                        <a:rPr sz="1400">
                           <a:solidFill>
                             <a:srgbClr val="30302F"/>
                           </a:solidFill>
-                          <a:latin typeface="Inter"/>
+                          <a:latin typeface="Arial"/>
                         </a:rPr>
                         <a:t>References</a:t>
                       </a:r>
@@ -39590,11 +39590,11 @@
                     <a:lstStyle/>
                     <a:p>
                       <a:r>
-                        <a:rPr sz="1000">
+                        <a:rPr sz="1400">
                           <a:solidFill>
                             <a:srgbClr val="30302F"/>
                           </a:solidFill>
-                          <a:latin typeface="Inter"/>
+                          <a:latin typeface="Arial"/>
                         </a:rPr>
                         <a:t>Key sources only (not a full bibliography)</a:t>
                       </a:r>
@@ -39608,11 +39608,11 @@
                     <a:lstStyle/>
                     <a:p>
                       <a:r>
-                        <a:rPr sz="1000">
+                        <a:rPr sz="1400">
                           <a:solidFill>
                             <a:srgbClr val="30302F"/>
                           </a:solidFill>
-                          <a:latin typeface="Inter"/>
+                          <a:latin typeface="Arial"/>
                         </a:rPr>
                         <a:t>3 to 5 citations</a:t>
                       </a:r>
@@ -39722,7 +39722,7 @@
                 <a:solidFill>
                   <a:srgbClr val="FFFFFF"/>
                 </a:solidFill>
-                <a:latin typeface="Inter"/>
+                <a:latin typeface="Arial"/>
               </a:rPr>
               <a:t>Slide 10: Writing tips</a:t>
             </a:r>
@@ -39753,11 +39753,11 @@
           <a:p>
             <a:pPr algn="l"/>
             <a:r>
-              <a:rPr sz="1400" b="0">
+              <a:rPr sz="1800" b="0">
                 <a:solidFill>
                   <a:srgbClr val="30302F"/>
                 </a:solidFill>
-                <a:latin typeface="Inter"/>
+                <a:latin typeface="Arial"/>
               </a:rPr>
               <a:t>Jargon translation table for ocean accounts:</a:t>
             </a:r>
@@ -39769,11 +39769,11 @@
               </a:spcBef>
             </a:pPr>
             <a:r>
-              <a:rPr sz="1400" b="0">
+              <a:rPr sz="1800" b="0">
                 <a:solidFill>
                   <a:srgbClr val="30302F"/>
                 </a:solidFill>
-                <a:latin typeface="Inter"/>
+                <a:latin typeface="Arial"/>
               </a:rPr>
               <a:t>General writing principles (from Evans and Cvitanovic, 2018; Baron, 2010):</a:t>
             </a:r>
@@ -39785,11 +39785,11 @@
               </a:spcBef>
             </a:pPr>
             <a:r>
-              <a:rPr sz="1400" b="0">
+              <a:rPr sz="1800" b="0">
                 <a:solidFill>
                   <a:srgbClr val="30302F"/>
                 </a:solidFill>
-                <a:latin typeface="Inter"/>
+                <a:latin typeface="Arial"/>
               </a:rPr>
               <a:t>  Lead with what you know, not what you do not know</a:t>
             </a:r>
@@ -39801,11 +39801,11 @@
               </a:spcBef>
             </a:pPr>
             <a:r>
-              <a:rPr sz="1400" b="0">
+              <a:rPr sz="1800" b="0">
                 <a:solidFill>
                   <a:srgbClr val="30302F"/>
                 </a:solidFill>
-                <a:latin typeface="Inter"/>
+                <a:latin typeface="Arial"/>
               </a:rPr>
               <a:t>  Use data where possible, but keep it simple -- one or two key numbers, not a full results table</a:t>
             </a:r>
@@ -39817,11 +39817,11 @@
               </a:spcBef>
             </a:pPr>
             <a:r>
-              <a:rPr sz="1400" b="0">
+              <a:rPr sz="1800" b="0">
                 <a:solidFill>
                   <a:srgbClr val="30302F"/>
                 </a:solidFill>
-                <a:latin typeface="Inter"/>
+                <a:latin typeface="Arial"/>
               </a:rPr>
               <a:t>  Do not include methods or statistical details</a:t>
             </a:r>
@@ -39833,11 +39833,11 @@
               </a:spcBef>
             </a:pPr>
             <a:r>
-              <a:rPr sz="1400" b="0">
+              <a:rPr sz="1800" b="0">
                 <a:solidFill>
                   <a:srgbClr val="30302F"/>
                 </a:solidFill>
-                <a:latin typeface="Inter"/>
+                <a:latin typeface="Arial"/>
               </a:rPr>
               <a:t>  Use specific examples: "mangrove loss of 200 ha" is stronger than "significant habitat loss"</a:t>
             </a:r>
@@ -39849,11 +39849,11 @@
               </a:spcBef>
             </a:pPr>
             <a:r>
-              <a:rPr sz="1400" b="0">
+              <a:rPr sz="1800" b="0">
                 <a:solidFill>
                   <a:srgbClr val="30302F"/>
                 </a:solidFill>
-                <a:latin typeface="Inter"/>
+                <a:latin typeface="Arial"/>
               </a:rPr>
               <a:t>  Acknowledge your expertise -- you earned it</a:t>
             </a:r>
@@ -39865,11 +39865,11 @@
               </a:spcBef>
             </a:pPr>
             <a:r>
-              <a:rPr sz="1400" b="0">
+              <a:rPr sz="1800" b="0">
                 <a:solidFill>
                   <a:srgbClr val="30302F"/>
                 </a:solidFill>
-                <a:latin typeface="Inter"/>
+                <a:latin typeface="Arial"/>
               </a:rPr>
               <a:t>  Different audiences need different framing of the same data</a:t>
             </a:r>
@@ -39905,11 +39905,11 @@
                     <a:lstStyle/>
                     <a:p>
                       <a:r>
-                        <a:rPr sz="1100" b="1">
+                        <a:rPr sz="1400" b="1">
                           <a:solidFill>
                             <a:srgbClr val="FFFFFF"/>
                           </a:solidFill>
-                          <a:latin typeface="Inter"/>
+                          <a:latin typeface="Arial"/>
                         </a:rPr>
                         <a:t>Technical term</a:t>
                       </a:r>
@@ -39927,11 +39927,11 @@
                     <a:lstStyle/>
                     <a:p>
                       <a:r>
-                        <a:rPr sz="1100" b="1">
+                        <a:rPr sz="1400" b="1">
                           <a:solidFill>
                             <a:srgbClr val="FFFFFF"/>
                           </a:solidFill>
-                          <a:latin typeface="Inter"/>
+                          <a:latin typeface="Arial"/>
                         </a:rPr>
                         <a:t>Plain language alternative</a:t>
                       </a:r>
@@ -39951,11 +39951,11 @@
                     <a:lstStyle/>
                     <a:p>
                       <a:r>
-                        <a:rPr sz="1000">
+                        <a:rPr sz="1400">
                           <a:solidFill>
                             <a:srgbClr val="30302F"/>
                           </a:solidFill>
-                          <a:latin typeface="Inter"/>
+                          <a:latin typeface="Arial"/>
                         </a:rPr>
                         <a:t>Ecosystem extent account</a:t>
                       </a:r>
@@ -39969,11 +39969,11 @@
                     <a:lstStyle/>
                     <a:p>
                       <a:r>
-                        <a:rPr sz="1000">
+                        <a:rPr sz="1400">
                           <a:solidFill>
                             <a:srgbClr val="30302F"/>
                           </a:solidFill>
-                          <a:latin typeface="Inter"/>
+                          <a:latin typeface="Arial"/>
                         </a:rPr>
                         <a:t>Tracking the area of habitats like reefs, mangroves, and seagrass</a:t>
                       </a:r>
@@ -39989,11 +39989,11 @@
                     <a:lstStyle/>
                     <a:p>
                       <a:r>
-                        <a:rPr sz="1000">
+                        <a:rPr sz="1400">
                           <a:solidFill>
                             <a:srgbClr val="30302F"/>
                           </a:solidFill>
-                          <a:latin typeface="Inter"/>
+                          <a:latin typeface="Arial"/>
                         </a:rPr>
                         <a:t>Condition index (CI)</a:t>
                       </a:r>
@@ -40007,11 +40007,11 @@
                     <a:lstStyle/>
                     <a:p>
                       <a:r>
-                        <a:rPr sz="1000">
+                        <a:rPr sz="1400">
                           <a:solidFill>
                             <a:srgbClr val="30302F"/>
                           </a:solidFill>
-                          <a:latin typeface="Inter"/>
+                          <a:latin typeface="Arial"/>
                         </a:rPr>
                         <a:t>A health score from 0 (degraded) to 1 (healthy)</a:t>
                       </a:r>
@@ -40027,11 +40027,11 @@
                     <a:lstStyle/>
                     <a:p>
                       <a:r>
-                        <a:rPr sz="1000">
+                        <a:rPr sz="1400">
                           <a:solidFill>
                             <a:srgbClr val="30302F"/>
                           </a:solidFill>
-                          <a:latin typeface="Inter"/>
+                          <a:latin typeface="Arial"/>
                         </a:rPr>
                         <a:t>SEEA EA framework</a:t>
                       </a:r>
@@ -40045,11 +40045,11 @@
                     <a:lstStyle/>
                     <a:p>
                       <a:r>
-                        <a:rPr sz="1000">
+                        <a:rPr sz="1400">
                           <a:solidFill>
                             <a:srgbClr val="30302F"/>
                           </a:solidFill>
-                          <a:latin typeface="Inter"/>
+                          <a:latin typeface="Arial"/>
                         </a:rPr>
                         <a:t>The UN's international standard for measuring ecosystems alongside economic data</a:t>
                       </a:r>
@@ -40065,11 +40065,11 @@
                     <a:lstStyle/>
                     <a:p>
                       <a:r>
-                        <a:rPr sz="1000">
+                        <a:rPr sz="1400">
                           <a:solidFill>
                             <a:srgbClr val="30302F"/>
                           </a:solidFill>
-                          <a:latin typeface="Inter"/>
+                          <a:latin typeface="Arial"/>
                         </a:rPr>
                         <a:t>Ecosystem services flow</a:t>
                       </a:r>
@@ -40083,11 +40083,11 @@
                     <a:lstStyle/>
                     <a:p>
                       <a:r>
-                        <a:rPr sz="1000">
+                        <a:rPr sz="1400">
                           <a:solidFill>
                             <a:srgbClr val="30302F"/>
                           </a:solidFill>
-                          <a:latin typeface="Inter"/>
+                          <a:latin typeface="Arial"/>
                         </a:rPr>
                         <a:t>The benefits nature provides, such as fish, coastal protection, and tourism</a:t>
                       </a:r>
@@ -40103,11 +40103,11 @@
                     <a:lstStyle/>
                     <a:p>
                       <a:r>
-                        <a:rPr sz="1000">
+                        <a:rPr sz="1400">
                           <a:solidFill>
                             <a:srgbClr val="30302F"/>
                           </a:solidFill>
-                          <a:latin typeface="Inter"/>
+                          <a:latin typeface="Arial"/>
                         </a:rPr>
                         <a:t>Reference level</a:t>
                       </a:r>
@@ -40121,11 +40121,11 @@
                     <a:lstStyle/>
                     <a:p>
                       <a:r>
-                        <a:rPr sz="1000">
+                        <a:rPr sz="1400">
                           <a:solidFill>
                             <a:srgbClr val="30302F"/>
                           </a:solidFill>
-                          <a:latin typeface="Inter"/>
+                          <a:latin typeface="Arial"/>
                         </a:rPr>
                         <a:t>The benchmark for a healthy ecosystem</a:t>
                       </a:r>
@@ -40141,11 +40141,11 @@
                     <a:lstStyle/>
                     <a:p>
                       <a:r>
-                        <a:rPr sz="1000">
+                        <a:rPr sz="1400">
                           <a:solidFill>
                             <a:srgbClr val="30302F"/>
                           </a:solidFill>
-                          <a:latin typeface="Inter"/>
+                          <a:latin typeface="Arial"/>
                         </a:rPr>
                         <a:t>Opening/closing stock</a:t>
                       </a:r>
@@ -40159,11 +40159,11 @@
                     <a:lstStyle/>
                     <a:p>
                       <a:r>
-                        <a:rPr sz="1000">
+                        <a:rPr sz="1400">
                           <a:solidFill>
                             <a:srgbClr val="30302F"/>
                           </a:solidFill>
-                          <a:latin typeface="Inter"/>
+                          <a:latin typeface="Arial"/>
                         </a:rPr>
                         <a:t>The state of the ecosystem at the start and end of the measurement period</a:t>
                       </a:r>
@@ -40179,11 +40179,11 @@
                     <a:lstStyle/>
                     <a:p>
                       <a:r>
-                        <a:rPr sz="1000">
+                        <a:rPr sz="1400">
                           <a:solidFill>
                             <a:srgbClr val="30302F"/>
                           </a:solidFill>
-                          <a:latin typeface="Inter"/>
+                          <a:latin typeface="Arial"/>
                         </a:rPr>
                         <a:t>Normalization</a:t>
                       </a:r>
@@ -40197,11 +40197,11 @@
                     <a:lstStyle/>
                     <a:p>
                       <a:r>
-                        <a:rPr sz="1000">
+                        <a:rPr sz="1400">
                           <a:solidFill>
                             <a:srgbClr val="30302F"/>
                           </a:solidFill>
-                          <a:latin typeface="Inter"/>
+                          <a:latin typeface="Arial"/>
                         </a:rPr>
                         <a:t>Converting different measurements to a common 0 to 1 scale</a:t>
                       </a:r>
@@ -40217,11 +40217,11 @@
                     <a:lstStyle/>
                     <a:p>
                       <a:r>
-                        <a:rPr sz="1000">
+                        <a:rPr sz="1400">
                           <a:solidFill>
                             <a:srgbClr val="30302F"/>
                           </a:solidFill>
-                          <a:latin typeface="Inter"/>
+                          <a:latin typeface="Arial"/>
                         </a:rPr>
                         <a:t>OESA</a:t>
                       </a:r>
@@ -40235,11 +40235,11 @@
                     <a:lstStyle/>
                     <a:p>
                       <a:r>
-                        <a:rPr sz="1000">
+                        <a:rPr sz="1400">
                           <a:solidFill>
                             <a:srgbClr val="30302F"/>
                           </a:solidFill>
-                          <a:latin typeface="Inter"/>
+                          <a:latin typeface="Arial"/>
                         </a:rPr>
                         <a:t>A measure of how much ocean industries contribute to the national economy</a:t>
                       </a:r>
@@ -40349,7 +40349,7 @@
                 <a:solidFill>
                   <a:srgbClr val="FFFFFF"/>
                 </a:solidFill>
-                <a:latin typeface="Inter"/>
+                <a:latin typeface="Arial"/>
               </a:rPr>
               <a:t>Slide 11: Real GOAP policy briefs -- one framework, many angles</a:t>
             </a:r>
@@ -40380,11 +40380,11 @@
           <a:p>
             <a:pPr algn="l"/>
             <a:r>
-              <a:rPr sz="1400" b="0">
+              <a:rPr sz="1800" b="0">
                 <a:solidFill>
                   <a:srgbClr val="30302F"/>
                 </a:solidFill>
-                <a:latin typeface="Inter"/>
+                <a:latin typeface="Arial"/>
               </a:rPr>
               <a:t>These briefs all draw on ocean accounts but speak to different audiences and policy processes:</a:t>
             </a:r>
@@ -40396,11 +40396,11 @@
               </a:spcBef>
             </a:pPr>
             <a:r>
-              <a:rPr sz="1400" b="0">
+              <a:rPr sz="1800" b="0">
                 <a:solidFill>
                   <a:srgbClr val="30302F"/>
                 </a:solidFill>
-                <a:latin typeface="Inter"/>
+                <a:latin typeface="Arial"/>
               </a:rPr>
               <a:t>Your brief does not need to cover all of ocean accounting. Pick one policy angle that matters to your reader and build around it.</a:t>
             </a:r>
@@ -40412,11 +40412,11 @@
               </a:spcBef>
             </a:pPr>
             <a:r>
-              <a:rPr sz="1400" b="0">
+              <a:rPr sz="1800" b="0">
                 <a:solidFill>
                   <a:srgbClr val="30302F"/>
                 </a:solidFill>
-                <a:latin typeface="Inter"/>
+                <a:latin typeface="Arial"/>
               </a:rPr>
               <a:t>Printed copies of three of these briefs are available to look at during the drafting exercise.</a:t>
             </a:r>
@@ -40453,11 +40453,11 @@
                     <a:lstStyle/>
                     <a:p>
                       <a:r>
-                        <a:rPr sz="1100" b="1">
+                        <a:rPr sz="1400" b="1">
                           <a:solidFill>
                             <a:srgbClr val="FFFFFF"/>
                           </a:solidFill>
-                          <a:latin typeface="Inter"/>
+                          <a:latin typeface="Arial"/>
                         </a:rPr>
                         <a:t>Brief</a:t>
                       </a:r>
@@ -40475,11 +40475,11 @@
                     <a:lstStyle/>
                     <a:p>
                       <a:r>
-                        <a:rPr sz="1100" b="1">
+                        <a:rPr sz="1400" b="1">
                           <a:solidFill>
                             <a:srgbClr val="FFFFFF"/>
                           </a:solidFill>
-                          <a:latin typeface="Inter"/>
+                          <a:latin typeface="Arial"/>
                         </a:rPr>
                         <a:t>Policy topic</a:t>
                       </a:r>
@@ -40497,11 +40497,11 @@
                     <a:lstStyle/>
                     <a:p>
                       <a:r>
-                        <a:rPr sz="1100" b="1">
+                        <a:rPr sz="1400" b="1">
                           <a:solidFill>
                             <a:srgbClr val="FFFFFF"/>
                           </a:solidFill>
-                          <a:latin typeface="Inter"/>
+                          <a:latin typeface="Arial"/>
                         </a:rPr>
                         <a:t>Target audience</a:t>
                       </a:r>
@@ -40521,11 +40521,11 @@
                     <a:lstStyle/>
                     <a:p>
                       <a:r>
-                        <a:rPr sz="1000">
+                        <a:rPr sz="1400">
                           <a:solidFill>
                             <a:srgbClr val="30302F"/>
                           </a:solidFill>
-                          <a:latin typeface="Inter"/>
+                          <a:latin typeface="Arial"/>
                         </a:rPr>
                         <a:t>Ocean Accounts and the GBF</a:t>
                       </a:r>
@@ -40539,11 +40539,11 @@
                     <a:lstStyle/>
                     <a:p>
                       <a:r>
-                        <a:rPr sz="1000">
+                        <a:rPr sz="1400">
                           <a:solidFill>
                             <a:srgbClr val="30302F"/>
                           </a:solidFill>
-                          <a:latin typeface="Inter"/>
+                          <a:latin typeface="Arial"/>
                         </a:rPr>
                         <a:t>Biodiversity targets, 30x30, NBSAPs</a:t>
                       </a:r>
@@ -40557,11 +40557,11 @@
                     <a:lstStyle/>
                     <a:p>
                       <a:r>
-                        <a:rPr sz="1000">
+                        <a:rPr sz="1400">
                           <a:solidFill>
                             <a:srgbClr val="30302F"/>
                           </a:solidFill>
-                          <a:latin typeface="Inter"/>
+                          <a:latin typeface="Arial"/>
                         </a:rPr>
                         <a:t>CBD focal points, environment ministries</a:t>
                       </a:r>
@@ -40577,11 +40577,11 @@
                     <a:lstStyle/>
                     <a:p>
                       <a:r>
-                        <a:rPr sz="1000">
+                        <a:rPr sz="1400">
                           <a:solidFill>
                             <a:srgbClr val="30302F"/>
                           </a:solidFill>
-                          <a:latin typeface="Inter"/>
+                          <a:latin typeface="Arial"/>
                         </a:rPr>
                         <a:t>Building Coastal Resilience</a:t>
                       </a:r>
@@ -40595,11 +40595,11 @@
                     <a:lstStyle/>
                     <a:p>
                       <a:r>
-                        <a:rPr sz="1000">
+                        <a:rPr sz="1400">
                           <a:solidFill>
                             <a:srgbClr val="30302F"/>
                           </a:solidFill>
-                          <a:latin typeface="Inter"/>
+                          <a:latin typeface="Arial"/>
                         </a:rPr>
                         <a:t>Disaster risk reduction, nature-based solutions</a:t>
                       </a:r>
@@ -40613,11 +40613,11 @@
                     <a:lstStyle/>
                     <a:p>
                       <a:r>
-                        <a:rPr sz="1000">
+                        <a:rPr sz="1400">
                           <a:solidFill>
                             <a:srgbClr val="30302F"/>
                           </a:solidFill>
-                          <a:latin typeface="Inter"/>
+                          <a:latin typeface="Arial"/>
                         </a:rPr>
                         <a:t>DRR agencies, climate adaptation planners</a:t>
                       </a:r>
@@ -40633,11 +40633,11 @@
                     <a:lstStyle/>
                     <a:p>
                       <a:r>
-                        <a:rPr sz="1000">
+                        <a:rPr sz="1400">
                           <a:solidFill>
                             <a:srgbClr val="30302F"/>
                           </a:solidFill>
-                          <a:latin typeface="Inter"/>
+                          <a:latin typeface="Arial"/>
                         </a:rPr>
                         <a:t>Mobilising Private Sector Investment</a:t>
                       </a:r>
@@ -40651,11 +40651,11 @@
                     <a:lstStyle/>
                     <a:p>
                       <a:r>
-                        <a:rPr sz="1000">
+                        <a:rPr sz="1400">
                           <a:solidFill>
                             <a:srgbClr val="30302F"/>
                           </a:solidFill>
-                          <a:latin typeface="Inter"/>
+                          <a:latin typeface="Arial"/>
                         </a:rPr>
                         <a:t>Blue bonds, bankability, risk reduction</a:t>
                       </a:r>
@@ -40669,11 +40669,11 @@
                     <a:lstStyle/>
                     <a:p>
                       <a:r>
-                        <a:rPr sz="1000">
+                        <a:rPr sz="1400">
                           <a:solidFill>
                             <a:srgbClr val="30302F"/>
                           </a:solidFill>
-                          <a:latin typeface="Inter"/>
+                          <a:latin typeface="Arial"/>
                         </a:rPr>
                         <a:t>Finance ministries, development banks, investors</a:t>
                       </a:r>
@@ -40689,11 +40689,11 @@
                     <a:lstStyle/>
                     <a:p>
                       <a:r>
-                        <a:rPr sz="1000">
+                        <a:rPr sz="1400">
                           <a:solidFill>
                             <a:srgbClr val="30302F"/>
                           </a:solidFill>
-                          <a:latin typeface="Inter"/>
+                          <a:latin typeface="Arial"/>
                         </a:rPr>
                         <a:t>Parametric Insurance</a:t>
                       </a:r>
@@ -40707,11 +40707,11 @@
                     <a:lstStyle/>
                     <a:p>
                       <a:r>
-                        <a:rPr sz="1000">
+                        <a:rPr sz="1400">
                           <a:solidFill>
                             <a:srgbClr val="30302F"/>
                           </a:solidFill>
-                          <a:latin typeface="Inter"/>
+                          <a:latin typeface="Arial"/>
                         </a:rPr>
                         <a:t>Insurance products tied to ecosystem health</a:t>
                       </a:r>
@@ -40725,11 +40725,11 @@
                     <a:lstStyle/>
                     <a:p>
                       <a:r>
-                        <a:rPr sz="1000">
+                        <a:rPr sz="1400">
                           <a:solidFill>
                             <a:srgbClr val="30302F"/>
                           </a:solidFill>
-                          <a:latin typeface="Inter"/>
+                          <a:latin typeface="Arial"/>
                         </a:rPr>
                         <a:t>Insurance sector, finance ministries</a:t>
                       </a:r>
@@ -40745,11 +40745,11 @@
                     <a:lstStyle/>
                     <a:p>
                       <a:r>
-                        <a:rPr sz="1000">
+                        <a:rPr sz="1400">
                           <a:solidFill>
                             <a:srgbClr val="30302F"/>
                           </a:solidFill>
-                          <a:latin typeface="Inter"/>
+                          <a:latin typeface="Arial"/>
                         </a:rPr>
                         <a:t>Plastics Data and MEAs</a:t>
                       </a:r>
@@ -40763,11 +40763,11 @@
                     <a:lstStyle/>
                     <a:p>
                       <a:r>
-                        <a:rPr sz="1000">
+                        <a:rPr sz="1400">
                           <a:solidFill>
                             <a:srgbClr val="30302F"/>
                           </a:solidFill>
-                          <a:latin typeface="Inter"/>
+                          <a:latin typeface="Arial"/>
                         </a:rPr>
                         <a:t>Plastic pollution monitoring, treaty reporting</a:t>
                       </a:r>
@@ -40781,11 +40781,11 @@
                     <a:lstStyle/>
                     <a:p>
                       <a:r>
-                        <a:rPr sz="1000">
+                        <a:rPr sz="1400">
                           <a:solidFill>
                             <a:srgbClr val="30302F"/>
                           </a:solidFill>
-                          <a:latin typeface="Inter"/>
+                          <a:latin typeface="Arial"/>
                         </a:rPr>
                         <a:t>Environment ministries, multilateral negotiations</a:t>
                       </a:r>
@@ -40801,11 +40801,11 @@
                     <a:lstStyle/>
                     <a:p>
                       <a:r>
-                        <a:rPr sz="1000">
+                        <a:rPr sz="1400">
                           <a:solidFill>
                             <a:srgbClr val="30302F"/>
                           </a:solidFill>
-                          <a:latin typeface="Inter"/>
+                          <a:latin typeface="Arial"/>
                         </a:rPr>
                         <a:t>Sustainable Marine Tourism</a:t>
                       </a:r>
@@ -40819,11 +40819,11 @@
                     <a:lstStyle/>
                     <a:p>
                       <a:r>
-                        <a:rPr sz="1000">
+                        <a:rPr sz="1400">
                           <a:solidFill>
                             <a:srgbClr val="30302F"/>
                           </a:solidFill>
-                          <a:latin typeface="Inter"/>
+                          <a:latin typeface="Arial"/>
                         </a:rPr>
                         <a:t>Tourism sustainability, ecosystem dependencies</a:t>
                       </a:r>
@@ -40837,11 +40837,11 @@
                     <a:lstStyle/>
                     <a:p>
                       <a:r>
-                        <a:rPr sz="1000">
+                        <a:rPr sz="1400">
                           <a:solidFill>
                             <a:srgbClr val="30302F"/>
                           </a:solidFill>
-                          <a:latin typeface="Inter"/>
+                          <a:latin typeface="Arial"/>
                         </a:rPr>
                         <a:t>Tourism boards, economic planning agencies</a:t>
                       </a:r>
@@ -40857,11 +40857,11 @@
                     <a:lstStyle/>
                     <a:p>
                       <a:r>
-                        <a:rPr sz="1000">
+                        <a:rPr sz="1400">
                           <a:solidFill>
                             <a:srgbClr val="30302F"/>
                           </a:solidFill>
-                          <a:latin typeface="Inter"/>
+                          <a:latin typeface="Arial"/>
                         </a:rPr>
                         <a:t>Public Finance Investment</a:t>
                       </a:r>
@@ -40875,11 +40875,11 @@
                     <a:lstStyle/>
                     <a:p>
                       <a:r>
-                        <a:rPr sz="1000">
+                        <a:rPr sz="1400">
                           <a:solidFill>
                             <a:srgbClr val="30302F"/>
                           </a:solidFill>
-                          <a:latin typeface="Inter"/>
+                          <a:latin typeface="Arial"/>
                         </a:rPr>
                         <a:t>Tracking impact of government ocean spending</a:t>
                       </a:r>
@@ -40893,11 +40893,11 @@
                     <a:lstStyle/>
                     <a:p>
                       <a:r>
-                        <a:rPr sz="1000">
+                        <a:rPr sz="1400">
                           <a:solidFill>
                             <a:srgbClr val="30302F"/>
                           </a:solidFill>
-                          <a:latin typeface="Inter"/>
+                          <a:latin typeface="Arial"/>
                         </a:rPr>
                         <a:t>Finance ministries, audit offices</a:t>
                       </a:r>
@@ -40913,11 +40913,11 @@
                     <a:lstStyle/>
                     <a:p>
                       <a:r>
-                        <a:rPr sz="1000">
+                        <a:rPr sz="1400">
                           <a:solidFill>
                             <a:srgbClr val="30302F"/>
                           </a:solidFill>
-                          <a:latin typeface="Inter"/>
+                          <a:latin typeface="Arial"/>
                         </a:rPr>
                         <a:t>IORA Cooperation</a:t>
                       </a:r>
@@ -40931,11 +40931,11 @@
                     <a:lstStyle/>
                     <a:p>
                       <a:r>
-                        <a:rPr sz="1000">
+                        <a:rPr sz="1400">
                           <a:solidFill>
                             <a:srgbClr val="30302F"/>
                           </a:solidFill>
-                          <a:latin typeface="Inter"/>
+                          <a:latin typeface="Arial"/>
                         </a:rPr>
                         <a:t>Regional blue economy collaboration</a:t>
                       </a:r>
@@ -40949,11 +40949,11 @@
                     <a:lstStyle/>
                     <a:p>
                       <a:r>
-                        <a:rPr sz="1000">
+                        <a:rPr sz="1400">
                           <a:solidFill>
                             <a:srgbClr val="30302F"/>
                           </a:solidFill>
-                          <a:latin typeface="Inter"/>
+                          <a:latin typeface="Arial"/>
                         </a:rPr>
                         <a:t>Indian Ocean Rim Association members</a:t>
                       </a:r>
@@ -41063,7 +41063,7 @@
                 <a:solidFill>
                   <a:srgbClr val="FFFFFF"/>
                 </a:solidFill>
-                <a:latin typeface="Inter"/>
+                <a:latin typeface="Arial"/>
               </a:rPr>
               <a:t>Slide 12: Your turn -- Draft your policy brief</a:t>
             </a:r>
@@ -41094,11 +41094,11 @@
           <a:p>
             <a:pPr algn="l"/>
             <a:r>
-              <a:rPr sz="1400" b="0">
+              <a:rPr sz="1800" b="0">
                 <a:solidFill>
                   <a:srgbClr val="30302F"/>
                 </a:solidFill>
-                <a:latin typeface="Inter"/>
+                <a:latin typeface="Arial"/>
               </a:rPr>
               <a:t>Time: 40 minutes drafting, then 15 minutes peer review</a:t>
             </a:r>
@@ -41110,11 +41110,11 @@
               </a:spcBef>
             </a:pPr>
             <a:r>
-              <a:rPr sz="1400" b="0">
+              <a:rPr sz="1800" b="0">
                 <a:solidFill>
                   <a:srgbClr val="30302F"/>
                 </a:solidFill>
-                <a:latin typeface="Inter"/>
+                <a:latin typeface="Arial"/>
               </a:rPr>
               <a:t>Use the policy brief template handout. Work through it section by section:</a:t>
             </a:r>
@@ -41126,11 +41126,11 @@
               </a:spcBef>
             </a:pPr>
             <a:r>
-              <a:rPr sz="1400" b="0">
+              <a:rPr sz="1800" b="0">
                 <a:solidFill>
                   <a:srgbClr val="30302F"/>
                 </a:solidFill>
-                <a:latin typeface="Inter"/>
+                <a:latin typeface="Arial"/>
               </a:rPr>
               <a:t>1. Title and context (10 min) -- name your country, your topic, and why it matters to your reader</a:t>
             </a:r>
@@ -41142,11 +41142,11 @@
               </a:spcBef>
             </a:pPr>
             <a:r>
-              <a:rPr sz="1400" b="0">
+              <a:rPr sz="1800" b="0">
                 <a:solidFill>
                   <a:srgbClr val="30302F"/>
                 </a:solidFill>
-                <a:latin typeface="Inter"/>
+                <a:latin typeface="Arial"/>
               </a:rPr>
               <a:t>2. What the accounts show (15 min) -- your key finding, with one number or table</a:t>
             </a:r>
@@ -41158,11 +41158,11 @@
               </a:spcBef>
             </a:pPr>
             <a:r>
-              <a:rPr sz="1400" b="0">
+              <a:rPr sz="1800" b="0">
                 <a:solidFill>
                   <a:srgbClr val="30302F"/>
                 </a:solidFill>
-                <a:latin typeface="Inter"/>
+                <a:latin typeface="Arial"/>
               </a:rPr>
               <a:t>3. Recommendations (10 min) -- 2 to 3 specific actions your reader can take</a:t>
             </a:r>
@@ -41174,11 +41174,11 @@
               </a:spcBef>
             </a:pPr>
             <a:r>
-              <a:rPr sz="1400" b="0">
+              <a:rPr sz="1800" b="0">
                 <a:solidFill>
                   <a:srgbClr val="30302F"/>
                 </a:solidFill>
-                <a:latin typeface="Inter"/>
+                <a:latin typeface="Arial"/>
               </a:rPr>
               <a:t>4. Key messages (5 min) -- write these last, after you know what your brief says</a:t>
             </a:r>
@@ -41190,11 +41190,11 @@
               </a:spcBef>
             </a:pPr>
             <a:r>
-              <a:rPr sz="1400" b="0">
+              <a:rPr sz="1800" b="0">
                 <a:solidFill>
                   <a:srgbClr val="30302F"/>
                 </a:solidFill>
-                <a:latin typeface="Inter"/>
+                <a:latin typeface="Arial"/>
               </a:rPr>
               <a:t>5. Peer review (15 min) -- swap with a neighbor, use the 8-item checklist</a:t>
             </a:r>
@@ -41206,11 +41206,11 @@
               </a:spcBef>
             </a:pPr>
             <a:r>
-              <a:rPr sz="1400" b="0">
+              <a:rPr sz="1800" b="0">
                 <a:solidFill>
                   <a:srgbClr val="30302F"/>
                 </a:solidFill>
-                <a:latin typeface="Inter"/>
+                <a:latin typeface="Arial"/>
               </a:rPr>
               <a:t>If you did not complete an account on Day 2, choose one of the printed GOAP briefs and reverse-engineer a Message Box from it. This is an excellent learning exercise.</a:t>
             </a:r>
@@ -41222,11 +41222,11 @@
               </a:spcBef>
             </a:pPr>
             <a:r>
-              <a:rPr sz="1400" b="0">
+              <a:rPr sz="1800" b="0">
                 <a:solidFill>
                   <a:srgbClr val="30302F"/>
                 </a:solidFill>
-                <a:latin typeface="Inter"/>
+                <a:latin typeface="Arial"/>
               </a:rPr>
               <a:t>Remember: this is a first draft. The goal is to get your ideas on paper, not to produce a finished document. You can refine it after the event with support from the GOAP Secretariat.</a:t>
             </a:r>
@@ -41330,7 +41330,7 @@
                 <a:solidFill>
                   <a:srgbClr val="FFFFFF"/>
                 </a:solidFill>
-                <a:latin typeface="Inter"/>
+                <a:latin typeface="Arial"/>
               </a:rPr>
               <a:t>References</a:t>
             </a:r>
@@ -41361,11 +41361,11 @@
           <a:p>
             <a:pPr algn="l"/>
             <a:r>
-              <a:rPr sz="1400" b="0">
+              <a:rPr sz="1800" b="0">
                 <a:solidFill>
                   <a:srgbClr val="30302F"/>
                 </a:solidFill>
-                <a:latin typeface="Inter"/>
+                <a:latin typeface="Arial"/>
               </a:rPr>
               <a:t>Baron, N. (2010). Escape from the Ivory Tower: A Guide to Making Your Science Matter. Island Press.</a:t>
             </a:r>
@@ -41377,11 +41377,11 @@
               </a:spcBef>
             </a:pPr>
             <a:r>
-              <a:rPr sz="1400" b="0">
+              <a:rPr sz="1800" b="0">
                 <a:solidFill>
                   <a:srgbClr val="30302F"/>
                 </a:solidFill>
-                <a:latin typeface="Inter"/>
+                <a:latin typeface="Arial"/>
               </a:rPr>
               <a:t>Cairney, P. and Heikkila, T. (2014). A comparison of theories of the policy process. In Sabatier, P.A. and Weible, C.M. (eds), Theories of the Policy Process. 3rd ed. Westview Press, pp. 363-389.</a:t>
             </a:r>
@@ -41393,11 +41393,11 @@
               </a:spcBef>
             </a:pPr>
             <a:r>
-              <a:rPr sz="1400" b="0">
+              <a:rPr sz="1800" b="0">
                 <a:solidFill>
                   <a:srgbClr val="30302F"/>
                 </a:solidFill>
-                <a:latin typeface="Inter"/>
+                <a:latin typeface="Arial"/>
               </a:rPr>
               <a:t>Evans, M.C. and Cvitanovic, C. (2018). An introduction to achieving policy impact for early career researchers. Palgrave Communications 4(88). DOI: 10.1057/s41599-018-0144-2.</a:t>
             </a:r>
@@ -41409,11 +41409,11 @@
               </a:spcBef>
             </a:pPr>
             <a:r>
-              <a:rPr sz="1400" b="0">
+              <a:rPr sz="1800" b="0">
                 <a:solidFill>
                   <a:srgbClr val="30302F"/>
                 </a:solidFill>
-                <a:latin typeface="Inter"/>
+                <a:latin typeface="Arial"/>
               </a:rPr>
               <a:t>COMPASS. The Message Box Workbook. Communication Partnership for Science and the Sea.</a:t>
             </a:r>
@@ -41517,7 +41517,7 @@
                 <a:solidFill>
                   <a:srgbClr val="FFFFFF"/>
                 </a:solidFill>
-                <a:latin typeface="Inter"/>
+                <a:latin typeface="Arial"/>
               </a:rPr>
               <a:t>References</a:t>
             </a:r>
@@ -41548,11 +41548,11 @@
           <a:p>
             <a:pPr algn="l"/>
             <a:r>
-              <a:rPr sz="1200" b="0">
+              <a:rPr sz="1800" b="0">
                 <a:solidFill>
                   <a:srgbClr val="30302F"/>
                 </a:solidFill>
-                <a:latin typeface="Inter"/>
+                <a:latin typeface="Arial"/>
               </a:rPr>
               <a:t>Baron, N. (2010). Escape from the Ivory Tower: A Guide to Making Your Science Matter. Island Press.</a:t>
             </a:r>
@@ -41564,11 +41564,11 @@
               </a:spcBef>
             </a:pPr>
             <a:r>
-              <a:rPr sz="1200" b="0">
+              <a:rPr sz="1800" b="0">
                 <a:solidFill>
                   <a:srgbClr val="30302F"/>
                 </a:solidFill>
-                <a:latin typeface="Inter"/>
+                <a:latin typeface="Arial"/>
               </a:rPr>
               <a:t>Cairney, P. and Heikkila, T. (2014). A comparison of theories of the policy process. In Theories of the Policy Process. 3rd ed. Westview Press.</a:t>
             </a:r>
@@ -41580,11 +41580,11 @@
               </a:spcBef>
             </a:pPr>
             <a:r>
-              <a:rPr sz="1200" b="0">
+              <a:rPr sz="1800" b="0">
                 <a:solidFill>
                   <a:srgbClr val="30302F"/>
                 </a:solidFill>
-                <a:latin typeface="Inter"/>
+                <a:latin typeface="Arial"/>
               </a:rPr>
               <a:t>Evans, M.C. and Cvitanovic, C. (2018). An introduction to achieving policy impact for early career researchers. Palgrave Communications 4(88).</a:t>
             </a:r>
@@ -41596,11 +41596,11 @@
               </a:spcBef>
             </a:pPr>
             <a:r>
-              <a:rPr sz="1200" b="0">
+              <a:rPr sz="1800" b="0">
                 <a:solidFill>
                   <a:srgbClr val="30302F"/>
                 </a:solidFill>
-                <a:latin typeface="Inter"/>
+                <a:latin typeface="Arial"/>
               </a:rPr>
               <a:t>COMPASS. The Message Box Workbook. Communication Partnership for Science and the Sea.</a:t>
             </a:r>
@@ -41704,7 +41704,7 @@
                 <a:solidFill>
                   <a:srgbClr val="FFFFFF"/>
                 </a:solidFill>
-                <a:latin typeface="Inter"/>
+                <a:latin typeface="Arial"/>
               </a:rPr>
               <a:t>Slide 1: What you will leave with today</a:t>
             </a:r>
@@ -41735,11 +41735,11 @@
           <a:p>
             <a:pPr algn="l"/>
             <a:r>
-              <a:rPr sz="1400" b="0">
+              <a:rPr sz="1800" b="0">
                 <a:solidFill>
                   <a:srgbClr val="30302F"/>
                 </a:solidFill>
-                <a:latin typeface="Inter"/>
+                <a:latin typeface="Arial"/>
               </a:rPr>
               <a:t>By the end of this session, you will have two things in hand:</a:t>
             </a:r>
@@ -41751,11 +41751,11 @@
               </a:spcBef>
             </a:pPr>
             <a:r>
-              <a:rPr sz="1400" b="0">
+              <a:rPr sz="1800" b="0">
                 <a:solidFill>
                   <a:srgbClr val="30302F"/>
                 </a:solidFill>
-                <a:latin typeface="Inter"/>
+                <a:latin typeface="Arial"/>
               </a:rPr>
               <a:t>1. A completed COMPASS Message Box that distils your ocean account results into a clear, audience-ready message</a:t>
             </a:r>
@@ -41767,11 +41767,11 @@
               </a:spcBef>
             </a:pPr>
             <a:r>
-              <a:rPr sz="1400" b="0">
+              <a:rPr sz="1800" b="0">
                 <a:solidFill>
                   <a:srgbClr val="30302F"/>
                 </a:solidFill>
-                <a:latin typeface="Inter"/>
+                <a:latin typeface="Arial"/>
               </a:rPr>
               <a:t>2. A draft policy brief that translates your account findings into a document a decision-maker can act on</a:t>
             </a:r>
@@ -41783,11 +41783,11 @@
               </a:spcBef>
             </a:pPr>
             <a:r>
-              <a:rPr sz="1400" b="0">
+              <a:rPr sz="1800" b="0">
                 <a:solidFill>
                   <a:srgbClr val="30302F"/>
                 </a:solidFill>
-                <a:latin typeface="Inter"/>
+                <a:latin typeface="Arial"/>
               </a:rPr>
               <a:t>This is hands-on. You will spend more time writing than listening.</a:t>
             </a:r>
@@ -41825,11 +41825,11 @@
                     <a:lstStyle/>
                     <a:p>
                       <a:r>
-                        <a:rPr sz="1100" b="1">
+                        <a:rPr sz="1400" b="1">
                           <a:solidFill>
                             <a:srgbClr val="FFFFFF"/>
                           </a:solidFill>
-                          <a:latin typeface="Inter"/>
+                          <a:latin typeface="Arial"/>
                         </a:rPr>
                         <a:t>Part</a:t>
                       </a:r>
@@ -41847,11 +41847,11 @@
                     <a:lstStyle/>
                     <a:p>
                       <a:r>
-                        <a:rPr sz="1100" b="1">
+                        <a:rPr sz="1400" b="1">
                           <a:solidFill>
                             <a:srgbClr val="FFFFFF"/>
                           </a:solidFill>
-                          <a:latin typeface="Inter"/>
+                          <a:latin typeface="Arial"/>
                         </a:rPr>
                         <a:t>Time</a:t>
                       </a:r>
@@ -41869,11 +41869,11 @@
                     <a:lstStyle/>
                     <a:p>
                       <a:r>
-                        <a:rPr sz="1100" b="1">
+                        <a:rPr sz="1400" b="1">
                           <a:solidFill>
                             <a:srgbClr val="FFFFFF"/>
                           </a:solidFill>
-                          <a:latin typeface="Inter"/>
+                          <a:latin typeface="Arial"/>
                         </a:rPr>
                         <a:t>Tool</a:t>
                       </a:r>
@@ -41891,11 +41891,11 @@
                     <a:lstStyle/>
                     <a:p>
                       <a:r>
-                        <a:rPr sz="1100" b="1">
+                        <a:rPr sz="1400" b="1">
                           <a:solidFill>
                             <a:srgbClr val="FFFFFF"/>
                           </a:solidFill>
-                          <a:latin typeface="Inter"/>
+                          <a:latin typeface="Arial"/>
                         </a:rPr>
                         <a:t>Output</a:t>
                       </a:r>
@@ -41915,11 +41915,11 @@
                     <a:lstStyle/>
                     <a:p>
                       <a:r>
-                        <a:rPr sz="1000">
+                        <a:rPr sz="1400">
                           <a:solidFill>
                             <a:srgbClr val="30302F"/>
                           </a:solidFill>
-                          <a:latin typeface="Inter"/>
+                          <a:latin typeface="Arial"/>
                         </a:rPr>
                         <a:t>Part 1</a:t>
                       </a:r>
@@ -41933,11 +41933,11 @@
                     <a:lstStyle/>
                     <a:p>
                       <a:r>
-                        <a:rPr sz="1000">
+                        <a:rPr sz="1400">
                           <a:solidFill>
                             <a:srgbClr val="30302F"/>
                           </a:solidFill>
-                          <a:latin typeface="Inter"/>
+                          <a:latin typeface="Arial"/>
                         </a:rPr>
                         <a:t>09:10-10:30</a:t>
                       </a:r>
@@ -41951,11 +41951,11 @@
                     <a:lstStyle/>
                     <a:p>
                       <a:r>
-                        <a:rPr sz="1000">
+                        <a:rPr sz="1400">
                           <a:solidFill>
                             <a:srgbClr val="30302F"/>
                           </a:solidFill>
-                          <a:latin typeface="Inter"/>
+                          <a:latin typeface="Arial"/>
                         </a:rPr>
                         <a:t>COMPASS Message Box</a:t>
                       </a:r>
@@ -41969,11 +41969,11 @@
                     <a:lstStyle/>
                     <a:p>
                       <a:r>
-                        <a:rPr sz="1000">
+                        <a:rPr sz="1400">
                           <a:solidFill>
                             <a:srgbClr val="30302F"/>
                           </a:solidFill>
-                          <a:latin typeface="Inter"/>
+                          <a:latin typeface="Arial"/>
                         </a:rPr>
                         <a:t>Your "elevator pitch" for ocean accounts</a:t>
                       </a:r>
@@ -41989,11 +41989,11 @@
                     <a:lstStyle/>
                     <a:p>
                       <a:r>
-                        <a:rPr sz="1000">
+                        <a:rPr sz="1400">
                           <a:solidFill>
                             <a:srgbClr val="30302F"/>
                           </a:solidFill>
-                          <a:latin typeface="Inter"/>
+                          <a:latin typeface="Arial"/>
                         </a:rPr>
                         <a:t>Part 2</a:t>
                       </a:r>
@@ -42007,11 +42007,11 @@
                     <a:lstStyle/>
                     <a:p>
                       <a:r>
-                        <a:rPr sz="1000">
+                        <a:rPr sz="1400">
                           <a:solidFill>
                             <a:srgbClr val="30302F"/>
                           </a:solidFill>
-                          <a:latin typeface="Inter"/>
+                          <a:latin typeface="Arial"/>
                         </a:rPr>
                         <a:t>10:45-12:00</a:t>
                       </a:r>
@@ -42025,11 +42025,11 @@
                     <a:lstStyle/>
                     <a:p>
                       <a:r>
-                        <a:rPr sz="1000">
+                        <a:rPr sz="1400">
                           <a:solidFill>
                             <a:srgbClr val="30302F"/>
                           </a:solidFill>
-                          <a:latin typeface="Inter"/>
+                          <a:latin typeface="Arial"/>
                         </a:rPr>
                         <a:t>Policy brief template</a:t>
                       </a:r>
@@ -42043,11 +42043,11 @@
                     <a:lstStyle/>
                     <a:p>
                       <a:r>
-                        <a:rPr sz="1000">
+                        <a:rPr sz="1400">
                           <a:solidFill>
                             <a:srgbClr val="30302F"/>
                           </a:solidFill>
-                          <a:latin typeface="Inter"/>
+                          <a:latin typeface="Arial"/>
                         </a:rPr>
                         <a:t>A 2-4 page draft brief</a:t>
                       </a:r>
@@ -42157,7 +42157,7 @@
                 <a:solidFill>
                   <a:srgbClr val="FFFFFF"/>
                 </a:solidFill>
-                <a:latin typeface="Inter"/>
+                <a:latin typeface="Arial"/>
               </a:rPr>
               <a:t>Slide 2: The science-policy gap</a:t>
             </a:r>
@@ -42188,11 +42188,11 @@
           <a:p>
             <a:pPr algn="l"/>
             <a:r>
-              <a:rPr sz="1400" b="0">
+              <a:rPr sz="1800" b="0">
                 <a:solidFill>
                   <a:srgbClr val="30302F"/>
                 </a:solidFill>
-                <a:latin typeface="Inter"/>
+                <a:latin typeface="Arial"/>
               </a:rPr>
               <a:t>Scientists and policymakers think about information in opposite order.</a:t>
             </a:r>
@@ -42204,11 +42204,11 @@
               </a:spcBef>
             </a:pPr>
             <a:r>
-              <a:rPr sz="1400" b="0">
+              <a:rPr sz="1800" b="0">
                 <a:solidFill>
                   <a:srgbClr val="30302F"/>
                 </a:solidFill>
-                <a:latin typeface="Inter"/>
+                <a:latin typeface="Arial"/>
               </a:rPr>
               <a:t>How scientists present:</a:t>
             </a:r>
@@ -42220,11 +42220,11 @@
               </a:spcBef>
             </a:pPr>
             <a:r>
-              <a:rPr sz="1400" b="0">
+              <a:rPr sz="1800" b="0">
                 <a:solidFill>
                   <a:srgbClr val="30302F"/>
                 </a:solidFill>
-                <a:latin typeface="Inter"/>
+                <a:latin typeface="Arial"/>
               </a:rPr>
               <a:t>1. Background and literature</a:t>
             </a:r>
@@ -42236,11 +42236,11 @@
               </a:spcBef>
             </a:pPr>
             <a:r>
-              <a:rPr sz="1400" b="0">
+              <a:rPr sz="1800" b="0">
                 <a:solidFill>
                   <a:srgbClr val="30302F"/>
                 </a:solidFill>
-                <a:latin typeface="Inter"/>
+                <a:latin typeface="Arial"/>
               </a:rPr>
               <a:t>2. Methods</a:t>
             </a:r>
@@ -42252,11 +42252,11 @@
               </a:spcBef>
             </a:pPr>
             <a:r>
-              <a:rPr sz="1400" b="0">
+              <a:rPr sz="1800" b="0">
                 <a:solidFill>
                   <a:srgbClr val="30302F"/>
                 </a:solidFill>
-                <a:latin typeface="Inter"/>
+                <a:latin typeface="Arial"/>
               </a:rPr>
               <a:t>3. Results</a:t>
             </a:r>
@@ -42268,11 +42268,11 @@
               </a:spcBef>
             </a:pPr>
             <a:r>
-              <a:rPr sz="1400" b="0">
+              <a:rPr sz="1800" b="0">
                 <a:solidFill>
                   <a:srgbClr val="30302F"/>
                 </a:solidFill>
-                <a:latin typeface="Inter"/>
+                <a:latin typeface="Arial"/>
               </a:rPr>
               <a:t>4. Conclusions</a:t>
             </a:r>
@@ -42284,11 +42284,11 @@
               </a:spcBef>
             </a:pPr>
             <a:r>
-              <a:rPr sz="1400" b="0">
+              <a:rPr sz="1800" b="0">
                 <a:solidFill>
                   <a:srgbClr val="30302F"/>
                 </a:solidFill>
-                <a:latin typeface="Inter"/>
+                <a:latin typeface="Arial"/>
               </a:rPr>
               <a:t>What policymakers want:</a:t>
             </a:r>
@@ -42300,11 +42300,11 @@
               </a:spcBef>
             </a:pPr>
             <a:r>
-              <a:rPr sz="1400" b="0">
+              <a:rPr sz="1800" b="0">
                 <a:solidFill>
                   <a:srgbClr val="30302F"/>
                 </a:solidFill>
-                <a:latin typeface="Inter"/>
+                <a:latin typeface="Arial"/>
               </a:rPr>
               <a:t>1. Results -- what did you find?</a:t>
             </a:r>
@@ -42316,11 +42316,11 @@
               </a:spcBef>
             </a:pPr>
             <a:r>
-              <a:rPr sz="1400" b="0">
+              <a:rPr sz="1800" b="0">
                 <a:solidFill>
                   <a:srgbClr val="30302F"/>
                 </a:solidFill>
-                <a:latin typeface="Inter"/>
+                <a:latin typeface="Arial"/>
               </a:rPr>
               <a:t>2. So what -- why does it matter for my decisions?</a:t>
             </a:r>
@@ -42332,11 +42332,11 @@
               </a:spcBef>
             </a:pPr>
             <a:r>
-              <a:rPr sz="1400" b="0">
+              <a:rPr sz="1800" b="0">
                 <a:solidFill>
                   <a:srgbClr val="30302F"/>
                 </a:solidFill>
-                <a:latin typeface="Inter"/>
+                <a:latin typeface="Arial"/>
               </a:rPr>
               <a:t>3. Background -- only if I need more detail</a:t>
             </a:r>
@@ -42348,11 +42348,11 @@
               </a:spcBef>
             </a:pPr>
             <a:r>
-              <a:rPr sz="1400" b="0">
+              <a:rPr sz="1800" b="0">
                 <a:solidFill>
                   <a:srgbClr val="30302F"/>
                 </a:solidFill>
-                <a:latin typeface="Inter"/>
+                <a:latin typeface="Arial"/>
               </a:rPr>
               <a:t>(Adapted from Baron, 2010. Escape from the Ivory Tower: A Guide to Making Your Science Matter.)</a:t>
             </a:r>
@@ -42364,11 +42364,11 @@
               </a:spcBef>
             </a:pPr>
             <a:r>
-              <a:rPr sz="1400" b="0">
+              <a:rPr sz="1800" b="0">
                 <a:solidFill>
                   <a:srgbClr val="30302F"/>
                 </a:solidFill>
-                <a:latin typeface="Inter"/>
+                <a:latin typeface="Arial"/>
               </a:rPr>
               <a:t>The challenge is not that your research is irrelevant. The challenge is that the way scientists are trained to communicate puts the most important information last. Policy briefs fix this by leading with findings and implications.</a:t>
             </a:r>
@@ -42472,7 +42472,7 @@
                 <a:solidFill>
                   <a:srgbClr val="FFFFFF"/>
                 </a:solidFill>
-                <a:latin typeface="Inter"/>
+                <a:latin typeface="Arial"/>
               </a:rPr>
               <a:t>Slide 3: Science is one input among many</a:t>
             </a:r>
@@ -42503,11 +42503,11 @@
           <a:p>
             <a:pPr algn="l"/>
             <a:r>
-              <a:rPr sz="1400" b="0">
+              <a:rPr sz="1800" b="0">
                 <a:solidFill>
                   <a:srgbClr val="30302F"/>
                 </a:solidFill>
-                <a:latin typeface="Inter"/>
+                <a:latin typeface="Arial"/>
               </a:rPr>
               <a:t>Policy decisions are shaped by six elements, not just evidence (Cairney and Heikkila, 2014):</a:t>
             </a:r>
@@ -42519,11 +42519,11 @@
               </a:spcBef>
             </a:pPr>
             <a:r>
-              <a:rPr sz="1400" b="0">
+              <a:rPr sz="1800" b="0">
                 <a:solidFill>
                   <a:srgbClr val="30302F"/>
                 </a:solidFill>
-                <a:latin typeface="Inter"/>
+                <a:latin typeface="Arial"/>
               </a:rPr>
               <a:t>Your ocean account results enter this system as evidence. A good policy brief positions your evidence within the elements your audience cares about.</a:t>
             </a:r>
@@ -42535,11 +42535,11 @@
               </a:spcBef>
             </a:pPr>
             <a:r>
-              <a:rPr sz="1400" b="0">
+              <a:rPr sz="1800" b="0">
                 <a:solidFill>
                   <a:srgbClr val="30302F"/>
                 </a:solidFill>
-                <a:latin typeface="Inter"/>
+                <a:latin typeface="Arial"/>
               </a:rPr>
               <a:t>(Evans and Cvitanovic, 2018)</a:t>
             </a:r>
@@ -42576,11 +42576,11 @@
                     <a:lstStyle/>
                     <a:p>
                       <a:r>
-                        <a:rPr sz="1100" b="1">
+                        <a:rPr sz="1400" b="1">
                           <a:solidFill>
                             <a:srgbClr val="FFFFFF"/>
                           </a:solidFill>
-                          <a:latin typeface="Inter"/>
+                          <a:latin typeface="Arial"/>
                         </a:rPr>
                         <a:t>Element</a:t>
                       </a:r>
@@ -42598,11 +42598,11 @@
                     <a:lstStyle/>
                     <a:p>
                       <a:r>
-                        <a:rPr sz="1100" b="1">
+                        <a:rPr sz="1400" b="1">
                           <a:solidFill>
                             <a:srgbClr val="FFFFFF"/>
                           </a:solidFill>
-                          <a:latin typeface="Inter"/>
+                          <a:latin typeface="Arial"/>
                         </a:rPr>
                         <a:t>What it means</a:t>
                       </a:r>
@@ -42620,11 +42620,11 @@
                     <a:lstStyle/>
                     <a:p>
                       <a:r>
-                        <a:rPr sz="1100" b="1">
+                        <a:rPr sz="1400" b="1">
                           <a:solidFill>
                             <a:srgbClr val="FFFFFF"/>
                           </a:solidFill>
-                          <a:latin typeface="Inter"/>
+                          <a:latin typeface="Arial"/>
                         </a:rPr>
                         <a:t>Example</a:t>
                       </a:r>
@@ -42644,11 +42644,11 @@
                     <a:lstStyle/>
                     <a:p>
                       <a:r>
-                        <a:rPr sz="1000">
+                        <a:rPr sz="1400">
                           <a:solidFill>
                             <a:srgbClr val="30302F"/>
                           </a:solidFill>
-                          <a:latin typeface="Inter"/>
+                          <a:latin typeface="Arial"/>
                         </a:rPr>
                         <a:t>Policy actors</a:t>
                       </a:r>
@@ -42662,11 +42662,11 @@
                     <a:lstStyle/>
                     <a:p>
                       <a:r>
-                        <a:rPr sz="1000">
+                        <a:rPr sz="1400">
                           <a:solidFill>
                             <a:srgbClr val="30302F"/>
                           </a:solidFill>
-                          <a:latin typeface="Inter"/>
+                          <a:latin typeface="Arial"/>
                         </a:rPr>
                         <a:t>People and organizations involved in the process</a:t>
                       </a:r>
@@ -42680,11 +42680,11 @@
                     <a:lstStyle/>
                     <a:p>
                       <a:r>
-                        <a:rPr sz="1000">
+                        <a:rPr sz="1400">
                           <a:solidFill>
                             <a:srgbClr val="30302F"/>
                           </a:solidFill>
-                          <a:latin typeface="Inter"/>
+                          <a:latin typeface="Arial"/>
                         </a:rPr>
                         <a:t>Ministry of Environment, fishing cooperatives, tourism boards</a:t>
                       </a:r>
@@ -42700,11 +42700,11 @@
                     <a:lstStyle/>
                     <a:p>
                       <a:r>
-                        <a:rPr sz="1000">
+                        <a:rPr sz="1400">
                           <a:solidFill>
                             <a:srgbClr val="30302F"/>
                           </a:solidFill>
-                          <a:latin typeface="Inter"/>
+                          <a:latin typeface="Arial"/>
                         </a:rPr>
                         <a:t>Networks</a:t>
                       </a:r>
@@ -42718,11 +42718,11 @@
                     <a:lstStyle/>
                     <a:p>
                       <a:r>
-                        <a:rPr sz="1000">
+                        <a:rPr sz="1400">
                           <a:solidFill>
                             <a:srgbClr val="30302F"/>
                           </a:solidFill>
-                          <a:latin typeface="Inter"/>
+                          <a:latin typeface="Arial"/>
                         </a:rPr>
                         <a:t>Relationships between actors</a:t>
                       </a:r>
@@ -42736,11 +42736,11 @@
                     <a:lstStyle/>
                     <a:p>
                       <a:r>
-                        <a:rPr sz="1000">
+                        <a:rPr sz="1400">
                           <a:solidFill>
                             <a:srgbClr val="30302F"/>
                           </a:solidFill>
-                          <a:latin typeface="Inter"/>
+                          <a:latin typeface="Arial"/>
                         </a:rPr>
                         <a:t>Regional fisheries management organizations, GOAP community</a:t>
                       </a:r>
@@ -42756,11 +42756,11 @@
                     <a:lstStyle/>
                     <a:p>
                       <a:r>
-                        <a:rPr sz="1000">
+                        <a:rPr sz="1400">
                           <a:solidFill>
                             <a:srgbClr val="30302F"/>
                           </a:solidFill>
-                          <a:latin typeface="Inter"/>
+                          <a:latin typeface="Arial"/>
                         </a:rPr>
                         <a:t>Institutions</a:t>
                       </a:r>
@@ -42774,11 +42774,11 @@
                     <a:lstStyle/>
                     <a:p>
                       <a:r>
-                        <a:rPr sz="1000">
+                        <a:rPr sz="1400">
                           <a:solidFill>
                             <a:srgbClr val="30302F"/>
                           </a:solidFill>
-                          <a:latin typeface="Inter"/>
+                          <a:latin typeface="Arial"/>
                         </a:rPr>
                         <a:t>Rules, norms, and traditions</a:t>
                       </a:r>
@@ -42792,11 +42792,11 @@
                     <a:lstStyle/>
                     <a:p>
                       <a:r>
-                        <a:rPr sz="1000">
+                        <a:rPr sz="1400">
                           <a:solidFill>
                             <a:srgbClr val="30302F"/>
                           </a:solidFill>
-                          <a:latin typeface="Inter"/>
+                          <a:latin typeface="Arial"/>
                         </a:rPr>
                         <a:t>National accounting standards, SEEA framework, budget cycles</a:t>
                       </a:r>
@@ -42812,11 +42812,11 @@
                     <a:lstStyle/>
                     <a:p>
                       <a:r>
-                        <a:rPr sz="1000">
+                        <a:rPr sz="1400">
                           <a:solidFill>
                             <a:srgbClr val="30302F"/>
                           </a:solidFill>
-                          <a:latin typeface="Inter"/>
+                          <a:latin typeface="Arial"/>
                         </a:rPr>
                         <a:t>Ideas</a:t>
                       </a:r>
@@ -42830,11 +42830,11 @@
                     <a:lstStyle/>
                     <a:p>
                       <a:r>
-                        <a:rPr sz="1000">
+                        <a:rPr sz="1400">
                           <a:solidFill>
                             <a:srgbClr val="30302F"/>
                           </a:solidFill>
-                          <a:latin typeface="Inter"/>
+                          <a:latin typeface="Arial"/>
                         </a:rPr>
                         <a:t>Beliefs and worldviews</a:t>
                       </a:r>
@@ -42848,11 +42848,11 @@
                     <a:lstStyle/>
                     <a:p>
                       <a:r>
-                        <a:rPr sz="1000">
+                        <a:rPr sz="1400">
                           <a:solidFill>
                             <a:srgbClr val="30302F"/>
                           </a:solidFill>
-                          <a:latin typeface="Inter"/>
+                          <a:latin typeface="Arial"/>
                         </a:rPr>
                         <a:t>"Blue economy" framing, sustainability vs growth priorities</a:t>
                       </a:r>
@@ -42868,11 +42868,11 @@
                     <a:lstStyle/>
                     <a:p>
                       <a:r>
-                        <a:rPr sz="1000">
+                        <a:rPr sz="1400">
                           <a:solidFill>
                             <a:srgbClr val="30302F"/>
                           </a:solidFill>
-                          <a:latin typeface="Inter"/>
+                          <a:latin typeface="Arial"/>
                         </a:rPr>
                         <a:t>Events</a:t>
                       </a:r>
@@ -42886,11 +42886,11 @@
                     <a:lstStyle/>
                     <a:p>
                       <a:r>
-                        <a:rPr sz="1000">
+                        <a:rPr sz="1400">
                           <a:solidFill>
                             <a:srgbClr val="30302F"/>
                           </a:solidFill>
-                          <a:latin typeface="Inter"/>
+                          <a:latin typeface="Arial"/>
                         </a:rPr>
                         <a:t>Shocks that open policy windows</a:t>
                       </a:r>
@@ -42904,11 +42904,11 @@
                     <a:lstStyle/>
                     <a:p>
                       <a:r>
-                        <a:rPr sz="1000">
+                        <a:rPr sz="1400">
                           <a:solidFill>
                             <a:srgbClr val="30302F"/>
                           </a:solidFill>
-                          <a:latin typeface="Inter"/>
+                          <a:latin typeface="Arial"/>
                         </a:rPr>
                         <a:t>Coral bleaching event, oil spill, new government, UNOC3</a:t>
                       </a:r>
@@ -42924,11 +42924,11 @@
                     <a:lstStyle/>
                     <a:p>
                       <a:r>
-                        <a:rPr sz="1000">
+                        <a:rPr sz="1400">
                           <a:solidFill>
                             <a:srgbClr val="30302F"/>
                           </a:solidFill>
-                          <a:latin typeface="Inter"/>
+                          <a:latin typeface="Arial"/>
                         </a:rPr>
                         <a:t>Socioeconomic context</a:t>
                       </a:r>
@@ -42942,11 +42942,11 @@
                     <a:lstStyle/>
                     <a:p>
                       <a:r>
-                        <a:rPr sz="1000">
+                        <a:rPr sz="1400">
                           <a:solidFill>
                             <a:srgbClr val="30302F"/>
                           </a:solidFill>
-                          <a:latin typeface="Inter"/>
+                          <a:latin typeface="Arial"/>
                         </a:rPr>
                         <a:t>Economic conditions, demographics</a:t>
                       </a:r>
@@ -42960,11 +42960,11 @@
                     <a:lstStyle/>
                     <a:p>
                       <a:r>
-                        <a:rPr sz="1000">
+                        <a:rPr sz="1400">
                           <a:solidFill>
                             <a:srgbClr val="30302F"/>
                           </a:solidFill>
-                          <a:latin typeface="Inter"/>
+                          <a:latin typeface="Arial"/>
                         </a:rPr>
                         <a:t>Coastal poverty rates, tourism dependency, climate exposure</a:t>
                       </a:r>
@@ -43074,7 +43074,7 @@
                 <a:solidFill>
                   <a:srgbClr val="FFFFFF"/>
                 </a:solidFill>
-                <a:latin typeface="Inter"/>
+                <a:latin typeface="Arial"/>
               </a:rPr>
               <a:t>Slide 4: Know your audience</a:t>
             </a:r>
@@ -43105,11 +43105,11 @@
           <a:p>
             <a:pPr algn="l"/>
             <a:r>
-              <a:rPr sz="1400" b="0">
+              <a:rPr sz="1800" b="0">
                 <a:solidFill>
                   <a:srgbClr val="30302F"/>
                 </a:solidFill>
-                <a:latin typeface="Inter"/>
+                <a:latin typeface="Arial"/>
               </a:rPr>
               <a:t>Different audiences ask different questions about the same information.</a:t>
             </a:r>
@@ -43121,11 +43121,11 @@
               </a:spcBef>
             </a:pPr>
             <a:r>
-              <a:rPr sz="1400" b="0">
+              <a:rPr sz="1800" b="0">
                 <a:solidFill>
                   <a:srgbClr val="30302F"/>
                 </a:solidFill>
-                <a:latin typeface="Inter"/>
+                <a:latin typeface="Arial"/>
               </a:rPr>
               <a:t>(Baron, 2010)</a:t>
             </a:r>
@@ -43137,11 +43137,11 @@
               </a:spcBef>
             </a:pPr>
             <a:r>
-              <a:rPr sz="1400" b="0">
+              <a:rPr sz="1800" b="0">
                 <a:solidFill>
                   <a:srgbClr val="30302F"/>
                 </a:solidFill>
-                <a:latin typeface="Inter"/>
+                <a:latin typeface="Arial"/>
               </a:rPr>
               <a:t>Before you write anything, name a specific person or office as your reader. "Policymakers" is too vague. Try: "The Director of Fisheries in my country" or "The NBSAP focal point at our Ministry of Environment."</a:t>
             </a:r>
@@ -43177,11 +43177,11 @@
                     <a:lstStyle/>
                     <a:p>
                       <a:r>
-                        <a:rPr sz="1100" b="1">
+                        <a:rPr sz="1400" b="1">
                           <a:solidFill>
                             <a:srgbClr val="FFFFFF"/>
                           </a:solidFill>
-                          <a:latin typeface="Inter"/>
+                          <a:latin typeface="Arial"/>
                         </a:rPr>
                         <a:t>Audience</a:t>
                       </a:r>
@@ -43199,11 +43199,11 @@
                     <a:lstStyle/>
                     <a:p>
                       <a:r>
-                        <a:rPr sz="1100" b="1">
+                        <a:rPr sz="1400" b="1">
                           <a:solidFill>
                             <a:srgbClr val="FFFFFF"/>
                           </a:solidFill>
-                          <a:latin typeface="Inter"/>
+                          <a:latin typeface="Arial"/>
                         </a:rPr>
                         <a:t>What they ask</a:t>
                       </a:r>
@@ -43223,11 +43223,11 @@
                     <a:lstStyle/>
                     <a:p>
                       <a:r>
-                        <a:rPr sz="1000">
+                        <a:rPr sz="1400">
                           <a:solidFill>
                             <a:srgbClr val="30302F"/>
                           </a:solidFill>
-                          <a:latin typeface="Inter"/>
+                          <a:latin typeface="Arial"/>
                         </a:rPr>
                         <a:t>Policymakers</a:t>
                       </a:r>
@@ -43241,11 +43241,11 @@
                     <a:lstStyle/>
                     <a:p>
                       <a:r>
-                        <a:rPr sz="1000">
+                        <a:rPr sz="1400">
                           <a:solidFill>
                             <a:srgbClr val="30302F"/>
                           </a:solidFill>
-                          <a:latin typeface="Inter"/>
+                          <a:latin typeface="Arial"/>
                         </a:rPr>
                         <a:t>Does this support my agenda? Do my constituents care?</a:t>
                       </a:r>
@@ -43261,11 +43261,11 @@
                     <a:lstStyle/>
                     <a:p>
                       <a:r>
-                        <a:rPr sz="1000">
+                        <a:rPr sz="1400">
                           <a:solidFill>
                             <a:srgbClr val="30302F"/>
                           </a:solidFill>
-                          <a:latin typeface="Inter"/>
+                          <a:latin typeface="Arial"/>
                         </a:rPr>
                         <a:t>Managers</a:t>
                       </a:r>
@@ -43279,11 +43279,11 @@
                     <a:lstStyle/>
                     <a:p>
                       <a:r>
-                        <a:rPr sz="1000">
+                        <a:rPr sz="1400">
                           <a:solidFill>
                             <a:srgbClr val="30302F"/>
                           </a:solidFill>
-                          <a:latin typeface="Inter"/>
+                          <a:latin typeface="Arial"/>
                         </a:rPr>
                         <a:t>What will it cost -- time, effort, money? Who supports this?</a:t>
                       </a:r>
@@ -43299,11 +43299,11 @@
                     <a:lstStyle/>
                     <a:p>
                       <a:r>
-                        <a:rPr sz="1000">
+                        <a:rPr sz="1400">
                           <a:solidFill>
                             <a:srgbClr val="30302F"/>
                           </a:solidFill>
-                          <a:latin typeface="Inter"/>
+                          <a:latin typeface="Arial"/>
                         </a:rPr>
                         <a:t>NGOs</a:t>
                       </a:r>
@@ -43317,11 +43317,11 @@
                     <a:lstStyle/>
                     <a:p>
                       <a:r>
-                        <a:rPr sz="1000">
+                        <a:rPr sz="1400">
                           <a:solidFill>
                             <a:srgbClr val="30302F"/>
                           </a:solidFill>
-                          <a:latin typeface="Inter"/>
+                          <a:latin typeface="Arial"/>
                         </a:rPr>
                         <a:t>How does this fit our agenda?</a:t>
                       </a:r>
@@ -43337,11 +43337,11 @@
                     <a:lstStyle/>
                     <a:p>
                       <a:r>
-                        <a:rPr sz="1000">
+                        <a:rPr sz="1400">
                           <a:solidFill>
                             <a:srgbClr val="30302F"/>
                           </a:solidFill>
-                          <a:latin typeface="Inter"/>
+                          <a:latin typeface="Arial"/>
                         </a:rPr>
                         <a:t>Scientists</a:t>
                       </a:r>
@@ -43355,11 +43355,11 @@
                     <a:lstStyle/>
                     <a:p>
                       <a:r>
-                        <a:rPr sz="1000">
+                        <a:rPr sz="1400">
                           <a:solidFill>
                             <a:srgbClr val="30302F"/>
                           </a:solidFill>
-                          <a:latin typeface="Inter"/>
+                          <a:latin typeface="Arial"/>
                         </a:rPr>
                         <a:t>Is it groundbreaking? Is it robust? How does it affect my work?</a:t>
                       </a:r>
@@ -43375,11 +43375,11 @@
                     <a:lstStyle/>
                     <a:p>
                       <a:r>
-                        <a:rPr sz="1000">
+                        <a:rPr sz="1400">
                           <a:solidFill>
                             <a:srgbClr val="30302F"/>
                           </a:solidFill>
-                          <a:latin typeface="Inter"/>
+                          <a:latin typeface="Arial"/>
                         </a:rPr>
                         <a:t>Media</a:t>
                       </a:r>
@@ -43393,11 +43393,11 @@
                     <a:lstStyle/>
                     <a:p>
                       <a:r>
-                        <a:rPr sz="1000">
+                        <a:rPr sz="1400">
                           <a:solidFill>
                             <a:srgbClr val="30302F"/>
                           </a:solidFill>
-                          <a:latin typeface="Inter"/>
+                          <a:latin typeface="Arial"/>
                         </a:rPr>
                         <a:t>Is it news? Will it sell? Is it a good story?</a:t>
                       </a:r>
@@ -43413,11 +43413,11 @@
                     <a:lstStyle/>
                     <a:p>
                       <a:r>
-                        <a:rPr sz="1000">
+                        <a:rPr sz="1400">
                           <a:solidFill>
                             <a:srgbClr val="30302F"/>
                           </a:solidFill>
-                          <a:latin typeface="Inter"/>
+                          <a:latin typeface="Arial"/>
                         </a:rPr>
                         <a:t>Foundations</a:t>
                       </a:r>
@@ -43431,11 +43431,11 @@
                     <a:lstStyle/>
                     <a:p>
                       <a:r>
-                        <a:rPr sz="1000">
+                        <a:rPr sz="1400">
                           <a:solidFill>
                             <a:srgbClr val="30302F"/>
                           </a:solidFill>
-                          <a:latin typeface="Inter"/>
+                          <a:latin typeface="Arial"/>
                         </a:rPr>
                         <a:t>Does this fit within our portfolio?</a:t>
                       </a:r>
@@ -43451,11 +43451,11 @@
                     <a:lstStyle/>
                     <a:p>
                       <a:r>
-                        <a:rPr sz="1000">
+                        <a:rPr sz="1400">
                           <a:solidFill>
                             <a:srgbClr val="30302F"/>
                           </a:solidFill>
-                          <a:latin typeface="Inter"/>
+                          <a:latin typeface="Arial"/>
                         </a:rPr>
                         <a:t>Communities</a:t>
                       </a:r>
@@ -43469,11 +43469,11 @@
                     <a:lstStyle/>
                     <a:p>
                       <a:r>
-                        <a:rPr sz="1000">
+                        <a:rPr sz="1400">
                           <a:solidFill>
                             <a:srgbClr val="30302F"/>
                           </a:solidFill>
-                          <a:latin typeface="Inter"/>
+                          <a:latin typeface="Arial"/>
                         </a:rPr>
                         <a:t>How does this affect safety, health, livelihoods, and natural resources?</a:t>
                       </a:r>
@@ -43583,7 +43583,7 @@
                 <a:solidFill>
                   <a:srgbClr val="FFFFFF"/>
                 </a:solidFill>
-                <a:latin typeface="Inter"/>
+                <a:latin typeface="Arial"/>
               </a:rPr>
               <a:t>Slide 5: Tool 1 -- The COMPASS Message Box</a:t>
             </a:r>
@@ -43614,11 +43614,11 @@
           <a:p>
             <a:pPr algn="l"/>
             <a:r>
-              <a:rPr sz="1400" b="0">
+              <a:rPr sz="1800" b="0">
                 <a:solidFill>
                   <a:srgbClr val="30302F"/>
                 </a:solidFill>
-                <a:latin typeface="Inter"/>
+                <a:latin typeface="Arial"/>
               </a:rPr>
               <a:t>The Message Box is a thinking tool that forces you to distil your research into five clear components. It was developed by COMPASS (Communication Partnership for Science and the Sea).</a:t>
             </a:r>
@@ -43630,11 +43630,11 @@
               </a:spcBef>
             </a:pPr>
             <a:r>
-              <a:rPr sz="1400" b="0">
+              <a:rPr sz="1800" b="0">
                 <a:solidFill>
                   <a:srgbClr val="30302F"/>
                 </a:solidFill>
-                <a:latin typeface="Inter"/>
+                <a:latin typeface="Arial"/>
               </a:rPr>
               <a:t>+--------------------------------------------------+</a:t>
             </a:r>
@@ -43646,11 +43646,11 @@
               </a:spcBef>
             </a:pPr>
             <a:r>
-              <a:rPr sz="1400" b="0">
+              <a:rPr sz="1800" b="0">
                 <a:solidFill>
                   <a:srgbClr val="30302F"/>
                 </a:solidFill>
-                <a:latin typeface="Inter"/>
+                <a:latin typeface="Arial"/>
               </a:rPr>
               <a:t>+----------+                        +---------------+</a:t>
             </a:r>
@@ -43662,11 +43662,11 @@
               </a:spcBef>
             </a:pPr>
             <a:r>
-              <a:rPr sz="1400" b="0">
+              <a:rPr sz="1800" b="0">
                 <a:solidFill>
                   <a:srgbClr val="30302F"/>
                 </a:solidFill>
-                <a:latin typeface="Inter"/>
+                <a:latin typeface="Arial"/>
               </a:rPr>
               <a:t>+----------+                        +---------------+</a:t>
             </a:r>
@@ -43678,11 +43678,11 @@
               </a:spcBef>
             </a:pPr>
             <a:r>
-              <a:rPr sz="1400" b="0">
+              <a:rPr sz="1800" b="0">
                 <a:solidFill>
                   <a:srgbClr val="30302F"/>
                 </a:solidFill>
-                <a:latin typeface="Inter"/>
+                <a:latin typeface="Arial"/>
               </a:rPr>
               <a:t>+--------------------------------------------------+</a:t>
             </a:r>
@@ -43694,11 +43694,11 @@
               </a:spcBef>
             </a:pPr>
             <a:r>
-              <a:rPr sz="1400" b="0">
+              <a:rPr sz="1800" b="0">
                 <a:solidFill>
                   <a:srgbClr val="30302F"/>
                 </a:solidFill>
-                <a:latin typeface="Inter"/>
+                <a:latin typeface="Arial"/>
               </a:rPr>
               <a:t>The Issue sits at the center. It is the overarching topic, summarized in a short clear phrase. The four surrounding sections build your case: what is wrong (Problems), why it matters (So What), what can be done (Solutions), and what improves if action is taken (Benefits).</a:t>
             </a:r>
@@ -43710,11 +43710,11 @@
               </a:spcBef>
             </a:pPr>
             <a:r>
-              <a:rPr sz="1400" b="0">
+              <a:rPr sz="1800" b="0">
                 <a:solidFill>
                   <a:srgbClr val="30302F"/>
                 </a:solidFill>
-                <a:latin typeface="Inter"/>
+                <a:latin typeface="Arial"/>
               </a:rPr>
               <a:t>Start with the Issue, then fill in the So What -- it is the hardest and most important section.</a:t>
             </a:r>
@@ -43749,11 +43749,11 @@
                     <a:lstStyle/>
                     <a:p>
                       <a:r>
-                        <a:rPr sz="1100" b="1">
+                        <a:rPr sz="1400" b="1">
                           <a:solidFill>
                             <a:srgbClr val="FFFFFF"/>
                           </a:solidFill>
-                          <a:latin typeface="Inter"/>
+                          <a:latin typeface="Arial"/>
                         </a:rPr>
                         <a:t>PROBLEMS</a:t>
                       </a:r>
@@ -43773,11 +43773,11 @@
                     <a:lstStyle/>
                     <a:p>
                       <a:r>
-                        <a:rPr sz="1000">
+                        <a:rPr sz="1400">
                           <a:solidFill>
                             <a:srgbClr val="30302F"/>
                           </a:solidFill>
-                          <a:latin typeface="Inter"/>
+                          <a:latin typeface="Arial"/>
                         </a:rPr>
                         <a:t>What specific problems exist?</a:t>
                       </a:r>
@@ -43888,11 +43888,11 @@
                     <a:lstStyle/>
                     <a:p>
                       <a:r>
-                        <a:rPr sz="1000">
+                        <a:rPr sz="1400">
                           <a:solidFill>
                             <a:srgbClr val="30302F"/>
                           </a:solidFill>
-                          <a:latin typeface="Inter"/>
+                          <a:latin typeface="Arial"/>
                         </a:rPr>
                         <a:t>BENEFITS</a:t>
                       </a:r>
@@ -43906,11 +43906,11 @@
                     <a:lstStyle/>
                     <a:p>
                       <a:r>
-                        <a:rPr sz="1000">
+                        <a:rPr sz="1400">
                           <a:solidFill>
                             <a:srgbClr val="30302F"/>
                           </a:solidFill>
-                          <a:latin typeface="Inter"/>
+                          <a:latin typeface="Arial"/>
                         </a:rPr>
                         <a:t>ISSUE</a:t>
                       </a:r>
@@ -43924,11 +43924,11 @@
                     <a:lstStyle/>
                     <a:p>
                       <a:r>
-                        <a:rPr sz="1000">
+                        <a:rPr sz="1400">
                           <a:solidFill>
                             <a:srgbClr val="30302F"/>
                           </a:solidFill>
-                          <a:latin typeface="Inter"/>
+                          <a:latin typeface="Arial"/>
                         </a:rPr>
                         <a:t>SO WHAT</a:t>
                       </a:r>
@@ -43962,11 +43962,11 @@
                     <a:lstStyle/>
                     <a:p>
                       <a:r>
-                        <a:rPr sz="1000">
+                        <a:rPr sz="1400">
                           <a:solidFill>
                             <a:srgbClr val="30302F"/>
                           </a:solidFill>
-                          <a:latin typeface="Inter"/>
+                          <a:latin typeface="Arial"/>
                         </a:rPr>
                         <a:t>(your overarching</a:t>
                       </a:r>
@@ -44000,11 +44000,11 @@
                     <a:lstStyle/>
                     <a:p>
                       <a:r>
-                        <a:rPr sz="1000">
+                        <a:rPr sz="1400">
                           <a:solidFill>
                             <a:srgbClr val="30302F"/>
                           </a:solidFill>
-                          <a:latin typeface="Inter"/>
+                          <a:latin typeface="Arial"/>
                         </a:rPr>
                         <a:t>What</a:t>
                       </a:r>
@@ -44018,11 +44018,11 @@
                     <a:lstStyle/>
                     <a:p>
                       <a:r>
-                        <a:rPr sz="1000">
+                        <a:rPr sz="1400">
                           <a:solidFill>
                             <a:srgbClr val="30302F"/>
                           </a:solidFill>
-                          <a:latin typeface="Inter"/>
+                          <a:latin typeface="Arial"/>
                         </a:rPr>
                         <a:t>ocean topic)</a:t>
                       </a:r>
@@ -44036,11 +44036,11 @@
                     <a:lstStyle/>
                     <a:p>
                       <a:r>
-                        <a:rPr sz="1000">
+                        <a:rPr sz="1400">
                           <a:solidFill>
                             <a:srgbClr val="30302F"/>
                           </a:solidFill>
-                          <a:latin typeface="Inter"/>
+                          <a:latin typeface="Arial"/>
                         </a:rPr>
                         <a:t>Why should</a:t>
                       </a:r>
@@ -44056,11 +44056,11 @@
                     <a:lstStyle/>
                     <a:p>
                       <a:r>
-                        <a:rPr sz="1000">
+                        <a:rPr sz="1400">
                           <a:solidFill>
                             <a:srgbClr val="30302F"/>
                           </a:solidFill>
-                          <a:latin typeface="Inter"/>
+                          <a:latin typeface="Arial"/>
                         </a:rPr>
                         <a:t>improves</a:t>
                       </a:r>
@@ -44092,11 +44092,11 @@
                     <a:lstStyle/>
                     <a:p>
                       <a:r>
-                        <a:rPr sz="1000">
+                        <a:rPr sz="1400">
                           <a:solidFill>
                             <a:srgbClr val="30302F"/>
                           </a:solidFill>
-                          <a:latin typeface="Inter"/>
+                          <a:latin typeface="Arial"/>
                         </a:rPr>
                         <a:t>your audience</a:t>
                       </a:r>
@@ -44112,11 +44112,11 @@
                     <a:lstStyle/>
                     <a:p>
                       <a:r>
-                        <a:rPr sz="1000">
+                        <a:rPr sz="1400">
                           <a:solidFill>
                             <a:srgbClr val="30302F"/>
                           </a:solidFill>
-                          <a:latin typeface="Inter"/>
+                          <a:latin typeface="Arial"/>
                         </a:rPr>
                         <a:t>if action</a:t>
                       </a:r>
@@ -44148,11 +44148,11 @@
                     <a:lstStyle/>
                     <a:p>
                       <a:r>
-                        <a:rPr sz="1000">
+                        <a:rPr sz="1400">
                           <a:solidFill>
                             <a:srgbClr val="30302F"/>
                           </a:solidFill>
-                          <a:latin typeface="Inter"/>
+                          <a:latin typeface="Arial"/>
                         </a:rPr>
                         <a:t>care?</a:t>
                       </a:r>
@@ -44168,11 +44168,11 @@
                     <a:lstStyle/>
                     <a:p>
                       <a:r>
-                        <a:rPr sz="1000">
+                        <a:rPr sz="1400">
                           <a:solidFill>
                             <a:srgbClr val="30302F"/>
                           </a:solidFill>
-                          <a:latin typeface="Inter"/>
+                          <a:latin typeface="Arial"/>
                         </a:rPr>
                         <a:t>is taken?</a:t>
                       </a:r>
@@ -44273,11 +44273,11 @@
                     <a:lstStyle/>
                     <a:p>
                       <a:r>
-                        <a:rPr sz="1000">
+                        <a:rPr sz="1400">
                           <a:solidFill>
                             <a:srgbClr val="30302F"/>
                           </a:solidFill>
-                          <a:latin typeface="Inter"/>
+                          <a:latin typeface="Arial"/>
                         </a:rPr>
                         <a:t>SOLUTIONS</a:t>
                       </a:r>
@@ -44293,11 +44293,11 @@
                     <a:lstStyle/>
                     <a:p>
                       <a:r>
-                        <a:rPr sz="1000">
+                        <a:rPr sz="1400">
                           <a:solidFill>
                             <a:srgbClr val="30302F"/>
                           </a:solidFill>
-                          <a:latin typeface="Inter"/>
+                          <a:latin typeface="Arial"/>
                         </a:rPr>
                         <a:t>What actions do the data support?</a:t>
                       </a:r>
@@ -44407,7 +44407,7 @@
                 <a:solidFill>
                   <a:srgbClr val="FFFFFF"/>
                 </a:solidFill>
-                <a:latin typeface="Inter"/>
+                <a:latin typeface="Arial"/>
               </a:rPr>
               <a:t>Slide 6: Message Box worked example -- Ocean accounts and the GBF</a:t>
             </a:r>
@@ -44438,11 +44438,11 @@
           <a:p>
             <a:pPr algn="l"/>
             <a:r>
-              <a:rPr sz="1400" b="0">
+              <a:rPr sz="1800" b="0">
                 <a:solidFill>
                   <a:srgbClr val="30302F"/>
                 </a:solidFill>
-                <a:latin typeface="Inter"/>
+                <a:latin typeface="Arial"/>
               </a:rPr>
               <a:t>Here is the GOAP policy brief on the Global Biodiversity Framework, mapped onto a Message Box:</a:t>
             </a:r>
@@ -44454,11 +44454,11 @@
               </a:spcBef>
             </a:pPr>
             <a:r>
-              <a:rPr sz="1400" b="0">
+              <a:rPr sz="1800" b="0">
                 <a:solidFill>
                   <a:srgbClr val="30302F"/>
                 </a:solidFill>
-                <a:latin typeface="Inter"/>
+                <a:latin typeface="Arial"/>
               </a:rPr>
               <a:t>Notice: no methods, no technical jargon, no "we used the AGRRA protocol." The Message Box strips your work down to what matters for the reader.</a:t>
             </a:r>
@@ -44494,11 +44494,11 @@
                     <a:lstStyle/>
                     <a:p>
                       <a:r>
-                        <a:rPr sz="1100" b="1">
+                        <a:rPr sz="1400" b="1">
                           <a:solidFill>
                             <a:srgbClr val="FFFFFF"/>
                           </a:solidFill>
-                          <a:latin typeface="Inter"/>
+                          <a:latin typeface="Arial"/>
                         </a:rPr>
                         <a:t>Section</a:t>
                       </a:r>
@@ -44516,11 +44516,11 @@
                     <a:lstStyle/>
                     <a:p>
                       <a:r>
-                        <a:rPr sz="1100" b="1">
+                        <a:rPr sz="1400" b="1">
                           <a:solidFill>
                             <a:srgbClr val="FFFFFF"/>
                           </a:solidFill>
-                          <a:latin typeface="Inter"/>
+                          <a:latin typeface="Arial"/>
                         </a:rPr>
                         <a:t>Content</a:t>
                       </a:r>
@@ -44540,11 +44540,11 @@
                     <a:lstStyle/>
                     <a:p>
                       <a:r>
-                        <a:rPr sz="1000">
+                        <a:rPr sz="1400">
                           <a:solidFill>
                             <a:srgbClr val="30302F"/>
                           </a:solidFill>
-                          <a:latin typeface="Inter"/>
+                          <a:latin typeface="Arial"/>
                         </a:rPr>
                         <a:t>Issue</a:t>
                       </a:r>
@@ -44558,11 +44558,11 @@
                     <a:lstStyle/>
                     <a:p>
                       <a:r>
-                        <a:rPr sz="1000">
+                        <a:rPr sz="1400">
                           <a:solidFill>
                             <a:srgbClr val="30302F"/>
                           </a:solidFill>
-                          <a:latin typeface="Inter"/>
+                          <a:latin typeface="Arial"/>
                         </a:rPr>
                         <a:t>Using ocean accounts to track progress on the Global Biodiversity Framework</a:t>
                       </a:r>
@@ -44578,11 +44578,11 @@
                     <a:lstStyle/>
                     <a:p>
                       <a:r>
-                        <a:rPr sz="1000">
+                        <a:rPr sz="1400">
                           <a:solidFill>
                             <a:srgbClr val="30302F"/>
                           </a:solidFill>
-                          <a:latin typeface="Inter"/>
+                          <a:latin typeface="Arial"/>
                         </a:rPr>
                         <a:t>Problems</a:t>
                       </a:r>
@@ -44596,11 +44596,11 @@
                     <a:lstStyle/>
                     <a:p>
                       <a:r>
-                        <a:rPr sz="1000">
+                        <a:rPr sz="1400">
                           <a:solidFill>
                             <a:srgbClr val="30302F"/>
                           </a:solidFill>
-                          <a:latin typeface="Inter"/>
+                          <a:latin typeface="Arial"/>
                         </a:rPr>
                         <a:t>Countries lack standardized data to report on GBF targets. Biodiversity data is fragmented across agencies. Monitoring systems do not connect environmental trends to economic or social outcomes.</a:t>
                       </a:r>
@@ -44616,11 +44616,11 @@
                     <a:lstStyle/>
                     <a:p>
                       <a:r>
-                        <a:rPr sz="1000">
+                        <a:rPr sz="1400">
                           <a:solidFill>
                             <a:srgbClr val="30302F"/>
                           </a:solidFill>
-                          <a:latin typeface="Inter"/>
+                          <a:latin typeface="Arial"/>
                         </a:rPr>
                         <a:t>So What</a:t>
                       </a:r>
@@ -44634,11 +44634,11 @@
                     <a:lstStyle/>
                     <a:p>
                       <a:r>
-                        <a:rPr sz="1000">
+                        <a:rPr sz="1400">
                           <a:solidFill>
                             <a:srgbClr val="30302F"/>
                           </a:solidFill>
-                          <a:latin typeface="Inter"/>
+                          <a:latin typeface="Arial"/>
                         </a:rPr>
                         <a:t>Without consistent measurement, countries cannot track whether the 30x30 target is being met, whether conservation spending is effective, or whether marine ecosystems are improving. The GBF requires reporting that current systems cannot deliver.</a:t>
                       </a:r>
@@ -44654,11 +44654,11 @@
                     <a:lstStyle/>
                     <a:p>
                       <a:r>
-                        <a:rPr sz="1000">
+                        <a:rPr sz="1400">
                           <a:solidFill>
                             <a:srgbClr val="30302F"/>
                           </a:solidFill>
-                          <a:latin typeface="Inter"/>
+                          <a:latin typeface="Arial"/>
                         </a:rPr>
                         <a:t>Solutions</a:t>
                       </a:r>
@@ -44672,11 +44672,11 @@
                     <a:lstStyle/>
                     <a:p>
                       <a:r>
-                        <a:rPr sz="1000">
+                        <a:rPr sz="1400">
                           <a:solidFill>
                             <a:srgbClr val="30302F"/>
                           </a:solidFill>
-                          <a:latin typeface="Inter"/>
+                          <a:latin typeface="Arial"/>
                         </a:rPr>
                         <a:t>Ocean accounts integrate environmental, economic, and social data under the SEEA framework. Extent and condition accounts track habitat and ecosystem health. Services accounts measure benefits. All are aligned with GBF targets 1 through 14.</a:t>
                       </a:r>
@@ -44692,11 +44692,11 @@
                     <a:lstStyle/>
                     <a:p>
                       <a:r>
-                        <a:rPr sz="1000">
+                        <a:rPr sz="1400">
                           <a:solidFill>
                             <a:srgbClr val="30302F"/>
                           </a:solidFill>
-                          <a:latin typeface="Inter"/>
+                          <a:latin typeface="Arial"/>
                         </a:rPr>
                         <a:t>Benefits</a:t>
                       </a:r>
@@ -44710,11 +44710,11 @@
                     <a:lstStyle/>
                     <a:p>
                       <a:r>
-                        <a:rPr sz="1000">
+                        <a:rPr sz="1400">
                           <a:solidFill>
                             <a:srgbClr val="30302F"/>
                           </a:solidFill>
-                          <a:latin typeface="Inter"/>
+                          <a:latin typeface="Arial"/>
                         </a:rPr>
                         <a:t>Countries can monitor NBSAPs with standardized data. Spatial planning becomes evidence-based. Restoration priorities are identified. Conservation effectiveness can be measured over time. Reporting to the CBD becomes consistent and comparable.</a:t>
                       </a:r>
@@ -44824,7 +44824,7 @@
                 <a:solidFill>
                   <a:srgbClr val="FFFFFF"/>
                 </a:solidFill>
-                <a:latin typeface="Inter"/>
+                <a:latin typeface="Arial"/>
               </a:rPr>
               <a:t>Slide 7: Your turn -- Complete your Message Box</a:t>
             </a:r>
@@ -44855,11 +44855,11 @@
           <a:p>
             <a:pPr algn="l"/>
             <a:r>
-              <a:rPr sz="1400" b="0">
+              <a:rPr sz="1800" b="0">
                 <a:solidFill>
                   <a:srgbClr val="30302F"/>
                 </a:solidFill>
-                <a:latin typeface="Inter"/>
+                <a:latin typeface="Arial"/>
               </a:rPr>
               <a:t>Time: 20 minutes individual work, then 10 minutes pair share</a:t>
             </a:r>
@@ -44871,11 +44871,11 @@
               </a:spcBef>
             </a:pPr>
             <a:r>
-              <a:rPr sz="1400" b="0">
+              <a:rPr sz="1800" b="0">
                 <a:solidFill>
                   <a:srgbClr val="30302F"/>
                 </a:solidFill>
-                <a:latin typeface="Inter"/>
+                <a:latin typeface="Arial"/>
               </a:rPr>
               <a:t>1. Write the name of your target audience (a specific person, office, or body) at the top of your Message Box template</a:t>
             </a:r>
@@ -44887,11 +44887,11 @@
               </a:spcBef>
             </a:pPr>
             <a:r>
-              <a:rPr sz="1400" b="0">
+              <a:rPr sz="1800" b="0">
                 <a:solidFill>
                   <a:srgbClr val="30302F"/>
                 </a:solidFill>
-                <a:latin typeface="Inter"/>
+                <a:latin typeface="Arial"/>
               </a:rPr>
               <a:t>2. Fill in the Issue -- your overarching ocean topic, in one short phrase</a:t>
             </a:r>
@@ -44903,11 +44903,11 @@
               </a:spcBef>
             </a:pPr>
             <a:r>
-              <a:rPr sz="1400" b="0">
+              <a:rPr sz="1800" b="0">
                 <a:solidFill>
                   <a:srgbClr val="30302F"/>
                 </a:solidFill>
-                <a:latin typeface="Inter"/>
+                <a:latin typeface="Arial"/>
               </a:rPr>
               <a:t>3. Fill in the So What -- this is the hardest part. Ask yourself: "If a minister read only one sentence from my box, which would it be?"</a:t>
             </a:r>
@@ -44919,11 +44919,11 @@
               </a:spcBef>
             </a:pPr>
             <a:r>
-              <a:rPr sz="1400" b="0">
+              <a:rPr sz="1800" b="0">
                 <a:solidFill>
                   <a:srgbClr val="30302F"/>
                 </a:solidFill>
-                <a:latin typeface="Inter"/>
+                <a:latin typeface="Arial"/>
               </a:rPr>
               <a:t>4. Fill in Problems, Solutions, and Benefits</a:t>
             </a:r>
@@ -44935,11 +44935,11 @@
               </a:spcBef>
             </a:pPr>
             <a:r>
-              <a:rPr sz="1400" b="0">
+              <a:rPr sz="1800" b="0">
                 <a:solidFill>
                   <a:srgbClr val="30302F"/>
                 </a:solidFill>
-                <a:latin typeface="Inter"/>
+                <a:latin typeface="Arial"/>
               </a:rPr>
               <a:t>5. When you finish, swap with your neighbor. Can they understand your So What without knowing your technical background?</a:t>
             </a:r>
@@ -44951,11 +44951,11 @@
               </a:spcBef>
             </a:pPr>
             <a:r>
-              <a:rPr sz="1400" b="0">
+              <a:rPr sz="1800" b="0">
                 <a:solidFill>
                   <a:srgbClr val="30302F"/>
                 </a:solidFill>
-                <a:latin typeface="Inter"/>
+                <a:latin typeface="Arial"/>
               </a:rPr>
               <a:t>Use the Message Box template handout. If you get stuck, look at the prompting questions on your exercise worksheet.</a:t>
             </a:r>
@@ -45059,7 +45059,7 @@
                 <a:solidFill>
                   <a:srgbClr val="FFFFFF"/>
                 </a:solidFill>
-                <a:latin typeface="Inter"/>
+                <a:latin typeface="Arial"/>
               </a:rPr>
               <a:t>Slide 8: Tool 2 -- The policy brief</a:t>
             </a:r>
@@ -45090,11 +45090,11 @@
           <a:p>
             <a:pPr algn="l"/>
             <a:r>
-              <a:rPr sz="1400" b="0">
+              <a:rPr sz="1800" b="0">
                 <a:solidFill>
                   <a:srgbClr val="30302F"/>
                 </a:solidFill>
-                <a:latin typeface="Inter"/>
+                <a:latin typeface="Arial"/>
               </a:rPr>
               <a:t>A policy brief is a short document (2 to 4 pages) that summarizes research for a non-technical audience and identifies policy responses.</a:t>
             </a:r>
@@ -45106,11 +45106,11 @@
               </a:spcBef>
             </a:pPr>
             <a:r>
-              <a:rPr sz="1400" b="0">
+              <a:rPr sz="1800" b="0">
                 <a:solidFill>
                   <a:srgbClr val="30302F"/>
                 </a:solidFill>
-                <a:latin typeface="Inter"/>
+                <a:latin typeface="Arial"/>
               </a:rPr>
               <a:t>What a policy brief is:</a:t>
             </a:r>
@@ -45122,11 +45122,11 @@
               </a:spcBef>
             </a:pPr>
             <a:r>
-              <a:rPr sz="1400" b="0">
+              <a:rPr sz="1800" b="0">
                 <a:solidFill>
                   <a:srgbClr val="30302F"/>
                 </a:solidFill>
-                <a:latin typeface="Inter"/>
+                <a:latin typeface="Arial"/>
               </a:rPr>
               <a:t>  Short: readable in 5 to 10 minutes</a:t>
             </a:r>
@@ -45138,11 +45138,11 @@
               </a:spcBef>
             </a:pPr>
             <a:r>
-              <a:rPr sz="1400" b="0">
+              <a:rPr sz="1800" b="0">
                 <a:solidFill>
                   <a:srgbClr val="30302F"/>
                 </a:solidFill>
-                <a:latin typeface="Inter"/>
+                <a:latin typeface="Arial"/>
               </a:rPr>
               <a:t>  Jargon-free: written for someone outside your field</a:t>
             </a:r>
@@ -45154,11 +45154,11 @@
               </a:spcBef>
             </a:pPr>
             <a:r>
-              <a:rPr sz="1400" b="0">
+              <a:rPr sz="1800" b="0">
                 <a:solidFill>
                   <a:srgbClr val="30302F"/>
                 </a:solidFill>
-                <a:latin typeface="Inter"/>
+                <a:latin typeface="Arial"/>
               </a:rPr>
               <a:t>  Actionable: includes specific recommendations</a:t>
             </a:r>
@@ -45170,11 +45170,11 @@
               </a:spcBef>
             </a:pPr>
             <a:r>
-              <a:rPr sz="1400" b="0">
+              <a:rPr sz="1800" b="0">
                 <a:solidFill>
                   <a:srgbClr val="30302F"/>
                 </a:solidFill>
-                <a:latin typeface="Inter"/>
+                <a:latin typeface="Arial"/>
               </a:rPr>
               <a:t>  Evidence-based: grounded in your data, not opinion</a:t>
             </a:r>
@@ -45186,11 +45186,11 @@
               </a:spcBef>
             </a:pPr>
             <a:r>
-              <a:rPr sz="1400" b="0">
+              <a:rPr sz="1800" b="0">
                 <a:solidFill>
                   <a:srgbClr val="30302F"/>
                 </a:solidFill>
-                <a:latin typeface="Inter"/>
+                <a:latin typeface="Arial"/>
               </a:rPr>
               <a:t>What a policy brief is not:</a:t>
             </a:r>
@@ -45202,11 +45202,11 @@
               </a:spcBef>
             </a:pPr>
             <a:r>
-              <a:rPr sz="1400" b="0">
+              <a:rPr sz="1800" b="0">
                 <a:solidFill>
                   <a:srgbClr val="30302F"/>
                 </a:solidFill>
-                <a:latin typeface="Inter"/>
+                <a:latin typeface="Arial"/>
               </a:rPr>
               <a:t>  A journal article summary</a:t>
             </a:r>
@@ -45218,11 +45218,11 @@
               </a:spcBef>
             </a:pPr>
             <a:r>
-              <a:rPr sz="1400" b="0">
+              <a:rPr sz="1800" b="0">
                 <a:solidFill>
                   <a:srgbClr val="30302F"/>
                 </a:solidFill>
-                <a:latin typeface="Inter"/>
+                <a:latin typeface="Arial"/>
               </a:rPr>
               <a:t>  A methods description</a:t>
             </a:r>
@@ -45234,11 +45234,11 @@
               </a:spcBef>
             </a:pPr>
             <a:r>
-              <a:rPr sz="1400" b="0">
+              <a:rPr sz="1800" b="0">
                 <a:solidFill>
                   <a:srgbClr val="30302F"/>
                 </a:solidFill>
-                <a:latin typeface="Inter"/>
+                <a:latin typeface="Arial"/>
               </a:rPr>
               <a:t>  A literature review</a:t>
             </a:r>
@@ -45250,11 +45250,11 @@
               </a:spcBef>
             </a:pPr>
             <a:r>
-              <a:rPr sz="1400" b="0">
+              <a:rPr sz="1800" b="0">
                 <a:solidFill>
                   <a:srgbClr val="30302F"/>
                 </a:solidFill>
-                <a:latin typeface="Inter"/>
+                <a:latin typeface="Arial"/>
               </a:rPr>
               <a:t>  An advocacy piece for a single position</a:t>
             </a:r>
@@ -45266,11 +45266,11 @@
               </a:spcBef>
             </a:pPr>
             <a:r>
-              <a:rPr sz="1400" b="0">
+              <a:rPr sz="1800" b="0">
                 <a:solidFill>
                   <a:srgbClr val="30302F"/>
                 </a:solidFill>
-                <a:latin typeface="Inter"/>
+                <a:latin typeface="Arial"/>
               </a:rPr>
               <a:t>From Evans and Cvitanovic (2018): a policy brief should "succinctly describe a particular issue, argue why it represents a policy problem, and identify possible policy responses."</a:t>
             </a:r>
@@ -45282,11 +45282,11 @@
               </a:spcBef>
             </a:pPr>
             <a:r>
-              <a:rPr sz="1400" b="0">
+              <a:rPr sz="1800" b="0">
                 <a:solidFill>
                   <a:srgbClr val="30302F"/>
                 </a:solidFill>
-                <a:latin typeface="Inter"/>
+                <a:latin typeface="Arial"/>
               </a:rPr>
               <a:t>Policy briefs work best when a relationship already exists with the target reader. An unsolicited brief sent to someone who has never heard of you is unlikely to be read. Build the relationship first; the brief becomes a tool in that conversation.</a:t>
             </a:r>

</xml_diff>